<commit_message>
chore: actualizar pitch deck y su script generador
Co-Authored-By: Claude Opus 4.8 <noreply@anthropic.com>
</commit_message>
<xml_diff>
--- a/Pitch_BBTI_ERP.pptx
+++ b/Pitch_BBTI_ERP.pptx
@@ -14,9 +14,15 @@
     <p:sldId id="262" r:id="rId8"/>
     <p:sldId id="263" r:id="rId9"/>
     <p:sldId id="264" r:id="rId10"/>
+    <p:sldId id="265" r:id="rId11"/>
+    <p:sldId id="266" r:id="rId12"/>
+    <p:sldId id="267" r:id="rId13"/>
+    <p:sldId id="268" r:id="rId14"/>
+    <p:sldId id="269" r:id="rId15"/>
+    <p:sldId id="270" r:id="rId16"/>
   </p:sldIdLst>
   <p:notesMasterIdLst>
-    <p:notesMasterId r:id="rId11"/>
+    <p:notesMasterId r:id="rId17"/>
   </p:notesMasterIdLst>
   <p:sldSz cx="9144000" cy="5143500"/>
   <p:notesSz cx="5143500" cy="9144000"/>
@@ -552,6 +558,534 @@
 </p:notes>
 </file>
 
+<file path=ppt/notesSlides/notesSlide10.xml><?xml version="1.0" encoding="utf-8"?>
+<p:notes xmlns:a="http://schemas.openxmlformats.org/drawingml/2006/main" xmlns:r="http://schemas.openxmlformats.org/officeDocument/2006/relationships" xmlns:p="http://schemas.openxmlformats.org/presentationml/2006/main">
+  <p:cSld>
+    <p:spTree>
+      <p:nvGrpSpPr>
+        <p:cNvPr id="1" name=""/>
+        <p:cNvGrpSpPr/>
+        <p:nvPr/>
+      </p:nvGrpSpPr>
+      <p:grpSpPr>
+        <a:xfrm>
+          <a:off x="0" y="0"/>
+          <a:ext cx="0" cy="0"/>
+          <a:chOff x="0" y="0"/>
+          <a:chExt cx="0" cy="0"/>
+        </a:xfrm>
+      </p:grpSpPr>
+      <p:sp>
+        <p:nvSpPr>
+          <p:cNvPr id="2" name="Slide Image Placeholder 1"/>
+          <p:cNvSpPr>
+            <a:spLocks noGrp="1" noRot="1" noChangeAspect="1"/>
+          </p:cNvSpPr>
+          <p:nvPr>
+            <p:ph type="sldImg"/>
+          </p:nvPr>
+        </p:nvSpPr>
+        <p:spPr/>
+      </p:sp>
+      <p:sp>
+        <p:nvSpPr>
+          <p:cNvPr id="3" name="Notes Placeholder 2"/>
+          <p:cNvSpPr>
+            <a:spLocks noGrp="1"/>
+          </p:cNvSpPr>
+          <p:nvPr>
+            <p:ph type="body" idx="1"/>
+          </p:nvPr>
+        </p:nvSpPr>
+        <p:spPr/>
+        <p:txBody>
+          <a:bodyPr/>
+          <a:lstStyle/>
+          <a:p>
+            <a:r>
+              <a:rPr lang="en-US" dirty="0"/>
+              <a:t>El inicio dejó de ser un panel técnico para convertirse en el tablero de mando del gerente. Cobrado contra por cobrar, entregas ordenadas con los retrasados arriba, y todo en lenguaje de planta. Si hay un proyecto retrasado, la tarjeta se pone roja sola: no hay que ir a buscar el problema, el problema salta a la vista.</a:t>
+            </a:r>
+            <a:endParaRPr lang="en-US" dirty="0"/>
+          </a:p>
+        </p:txBody>
+      </p:sp>
+      <p:sp>
+        <p:nvSpPr>
+          <p:cNvPr id="4" name="Slide Number Placeholder 3"/>
+          <p:cNvSpPr>
+            <a:spLocks noGrp="1"/>
+          </p:cNvSpPr>
+          <p:nvPr>
+            <p:ph type="sldNum" sz="quarter" idx="10"/>
+          </p:nvPr>
+        </p:nvSpPr>
+        <p:spPr/>
+        <p:txBody>
+          <a:bodyPr/>
+          <a:lstStyle/>
+          <a:p>
+            <a:fld id="{F7021451-1387-4CA6-816F-3879F97B5CBC}" type="slidenum">
+              <a:rPr lang="en-US"/>
+              <a:t>10</a:t>
+            </a:fld>
+            <a:endParaRPr lang="en-US"/>
+          </a:p>
+        </p:txBody>
+      </p:sp>
+    </p:spTree>
+    <p:extLst>
+      <p:ext uri="{BB962C8B-B14F-4D97-AF65-F5344CB8AC3E}">
+        <p14:creationId xmlns:p14="http://schemas.microsoft.com/office/powerpoint/2010/main" val="1024086991"/>
+      </p:ext>
+    </p:extLst>
+  </p:cSld>
+  <p:clrMapOvr>
+    <a:masterClrMapping/>
+  </p:clrMapOvr>
+</p:notes>
+</file>
+
+<file path=ppt/notesSlides/notesSlide11.xml><?xml version="1.0" encoding="utf-8"?>
+<p:notes xmlns:a="http://schemas.openxmlformats.org/drawingml/2006/main" xmlns:r="http://schemas.openxmlformats.org/officeDocument/2006/relationships" xmlns:p="http://schemas.openxmlformats.org/presentationml/2006/main">
+  <p:cSld>
+    <p:spTree>
+      <p:nvGrpSpPr>
+        <p:cNvPr id="1" name=""/>
+        <p:cNvGrpSpPr/>
+        <p:nvPr/>
+      </p:nvGrpSpPr>
+      <p:grpSpPr>
+        <a:xfrm>
+          <a:off x="0" y="0"/>
+          <a:ext cx="0" cy="0"/>
+          <a:chOff x="0" y="0"/>
+          <a:chExt cx="0" cy="0"/>
+        </a:xfrm>
+      </p:grpSpPr>
+      <p:sp>
+        <p:nvSpPr>
+          <p:cNvPr id="2" name="Slide Image Placeholder 1"/>
+          <p:cNvSpPr>
+            <a:spLocks noGrp="1" noRot="1" noChangeAspect="1"/>
+          </p:cNvSpPr>
+          <p:nvPr>
+            <p:ph type="sldImg"/>
+          </p:nvPr>
+        </p:nvSpPr>
+        <p:spPr/>
+      </p:sp>
+      <p:sp>
+        <p:nvSpPr>
+          <p:cNvPr id="3" name="Notes Placeholder 2"/>
+          <p:cNvSpPr>
+            <a:spLocks noGrp="1"/>
+          </p:cNvSpPr>
+          <p:nvPr>
+            <p:ph type="body" idx="1"/>
+          </p:nvPr>
+        </p:nvSpPr>
+        <p:spPr/>
+        <p:txBody>
+          <a:bodyPr/>
+          <a:lstStyle/>
+          <a:p>
+            <a:r>
+              <a:rPr lang="en-US" dirty="0"/>
+              <a:t>Esta es la mejora que más se siente. El feed ya no espera 10 segundos: en cuanto alguien firma una etapa o registra un pago, aparece al instante con un destello y un sonido suave. La gerencia puede tener esta pantalla abierta y enterarse de todo lo que pasa en la planta sin hacer una sola llamada.</a:t>
+            </a:r>
+            <a:endParaRPr lang="en-US" dirty="0"/>
+          </a:p>
+        </p:txBody>
+      </p:sp>
+      <p:sp>
+        <p:nvSpPr>
+          <p:cNvPr id="4" name="Slide Number Placeholder 3"/>
+          <p:cNvSpPr>
+            <a:spLocks noGrp="1"/>
+          </p:cNvSpPr>
+          <p:nvPr>
+            <p:ph type="sldNum" sz="quarter" idx="10"/>
+          </p:nvPr>
+        </p:nvSpPr>
+        <p:spPr/>
+        <p:txBody>
+          <a:bodyPr/>
+          <a:lstStyle/>
+          <a:p>
+            <a:fld id="{F7021451-1387-4CA6-816F-3879F97B5CBC}" type="slidenum">
+              <a:rPr lang="en-US"/>
+              <a:t>11</a:t>
+            </a:fld>
+            <a:endParaRPr lang="en-US"/>
+          </a:p>
+        </p:txBody>
+      </p:sp>
+    </p:spTree>
+    <p:extLst>
+      <p:ext uri="{BB962C8B-B14F-4D97-AF65-F5344CB8AC3E}">
+        <p14:creationId xmlns:p14="http://schemas.microsoft.com/office/powerpoint/2010/main" val="1024086991"/>
+      </p:ext>
+    </p:extLst>
+  </p:cSld>
+  <p:clrMapOvr>
+    <a:masterClrMapping/>
+  </p:clrMapOvr>
+</p:notes>
+</file>
+
+<file path=ppt/notesSlides/notesSlide12.xml><?xml version="1.0" encoding="utf-8"?>
+<p:notes xmlns:a="http://schemas.openxmlformats.org/drawingml/2006/main" xmlns:r="http://schemas.openxmlformats.org/officeDocument/2006/relationships" xmlns:p="http://schemas.openxmlformats.org/presentationml/2006/main">
+  <p:cSld>
+    <p:spTree>
+      <p:nvGrpSpPr>
+        <p:cNvPr id="1" name=""/>
+        <p:cNvGrpSpPr/>
+        <p:nvPr/>
+      </p:nvGrpSpPr>
+      <p:grpSpPr>
+        <a:xfrm>
+          <a:off x="0" y="0"/>
+          <a:ext cx="0" cy="0"/>
+          <a:chOff x="0" y="0"/>
+          <a:chExt cx="0" cy="0"/>
+        </a:xfrm>
+      </p:grpSpPr>
+      <p:sp>
+        <p:nvSpPr>
+          <p:cNvPr id="2" name="Slide Image Placeholder 1"/>
+          <p:cNvSpPr>
+            <a:spLocks noGrp="1" noRot="1" noChangeAspect="1"/>
+          </p:cNvSpPr>
+          <p:nvPr>
+            <p:ph type="sldImg"/>
+          </p:nvPr>
+        </p:nvSpPr>
+        <p:spPr/>
+      </p:sp>
+      <p:sp>
+        <p:nvSpPr>
+          <p:cNvPr id="3" name="Notes Placeholder 2"/>
+          <p:cNvSpPr>
+            <a:spLocks noGrp="1"/>
+          </p:cNvSpPr>
+          <p:nvPr>
+            <p:ph type="body" idx="1"/>
+          </p:nvPr>
+        </p:nvSpPr>
+        <p:spPr/>
+        <p:txBody>
+          <a:bodyPr/>
+          <a:lstStyle/>
+          <a:p>
+            <a:r>
+              <a:rPr lang="en-US" dirty="0"/>
+              <a:t>Antes, un retraso se descubría cuando ya era tarde. Ahora hay un robot que cada mañana revisa los plazos y avisa con anticipación, pero con criterio: le habla solo al área responsable de la etapa atascada, una sola vez, y con los días de margen que la gerencia configure. Si se mueve la fecha de entrega, el aviso se reinicia automáticamente.</a:t>
+            </a:r>
+            <a:endParaRPr lang="en-US" dirty="0"/>
+          </a:p>
+        </p:txBody>
+      </p:sp>
+      <p:sp>
+        <p:nvSpPr>
+          <p:cNvPr id="4" name="Slide Number Placeholder 3"/>
+          <p:cNvSpPr>
+            <a:spLocks noGrp="1"/>
+          </p:cNvSpPr>
+          <p:nvPr>
+            <p:ph type="sldNum" sz="quarter" idx="10"/>
+          </p:nvPr>
+        </p:nvSpPr>
+        <p:spPr/>
+        <p:txBody>
+          <a:bodyPr/>
+          <a:lstStyle/>
+          <a:p>
+            <a:fld id="{F7021451-1387-4CA6-816F-3879F97B5CBC}" type="slidenum">
+              <a:rPr lang="en-US"/>
+              <a:t>12</a:t>
+            </a:fld>
+            <a:endParaRPr lang="en-US"/>
+          </a:p>
+        </p:txBody>
+      </p:sp>
+    </p:spTree>
+    <p:extLst>
+      <p:ext uri="{BB962C8B-B14F-4D97-AF65-F5344CB8AC3E}">
+        <p14:creationId xmlns:p14="http://schemas.microsoft.com/office/powerpoint/2010/main" val="1024086991"/>
+      </p:ext>
+    </p:extLst>
+  </p:cSld>
+  <p:clrMapOvr>
+    <a:masterClrMapping/>
+  </p:clrMapOvr>
+</p:notes>
+</file>
+
+<file path=ppt/notesSlides/notesSlide13.xml><?xml version="1.0" encoding="utf-8"?>
+<p:notes xmlns:a="http://schemas.openxmlformats.org/drawingml/2006/main" xmlns:r="http://schemas.openxmlformats.org/officeDocument/2006/relationships" xmlns:p="http://schemas.openxmlformats.org/presentationml/2006/main">
+  <p:cSld>
+    <p:spTree>
+      <p:nvGrpSpPr>
+        <p:cNvPr id="1" name=""/>
+        <p:cNvGrpSpPr/>
+        <p:nvPr/>
+      </p:nvGrpSpPr>
+      <p:grpSpPr>
+        <a:xfrm>
+          <a:off x="0" y="0"/>
+          <a:ext cx="0" cy="0"/>
+          <a:chOff x="0" y="0"/>
+          <a:chExt cx="0" cy="0"/>
+        </a:xfrm>
+      </p:grpSpPr>
+      <p:sp>
+        <p:nvSpPr>
+          <p:cNvPr id="2" name="Slide Image Placeholder 1"/>
+          <p:cNvSpPr>
+            <a:spLocks noGrp="1" noRot="1" noChangeAspect="1"/>
+          </p:cNvSpPr>
+          <p:nvPr>
+            <p:ph type="sldImg"/>
+          </p:nvPr>
+        </p:nvSpPr>
+        <p:spPr/>
+      </p:sp>
+      <p:sp>
+        <p:nvSpPr>
+          <p:cNvPr id="3" name="Notes Placeholder 2"/>
+          <p:cNvSpPr>
+            <a:spLocks noGrp="1"/>
+          </p:cNvSpPr>
+          <p:nvPr>
+            <p:ph type="body" idx="1"/>
+          </p:nvPr>
+        </p:nvSpPr>
+        <p:spPr/>
+        <p:txBody>
+          <a:bodyPr/>
+          <a:lstStyle/>
+          <a:p>
+            <a:r>
+              <a:rPr lang="en-US" dirty="0"/>
+              <a:t>Este panel mide avance del trabajo, no presencia: cuenta los hitos que de verdad mueven un proyecto. Distingue una firma de etapa o una compra de una simple edición rutinaria, y marca en rojo a quien no tuvo movimientos. Es una herramienta de gestión justa, basada en resultados visibles en el sistema.</a:t>
+            </a:r>
+            <a:endParaRPr lang="en-US" dirty="0"/>
+          </a:p>
+        </p:txBody>
+      </p:sp>
+      <p:sp>
+        <p:nvSpPr>
+          <p:cNvPr id="4" name="Slide Number Placeholder 3"/>
+          <p:cNvSpPr>
+            <a:spLocks noGrp="1"/>
+          </p:cNvSpPr>
+          <p:nvPr>
+            <p:ph type="sldNum" sz="quarter" idx="10"/>
+          </p:nvPr>
+        </p:nvSpPr>
+        <p:spPr/>
+        <p:txBody>
+          <a:bodyPr/>
+          <a:lstStyle/>
+          <a:p>
+            <a:fld id="{F7021451-1387-4CA6-816F-3879F97B5CBC}" type="slidenum">
+              <a:rPr lang="en-US"/>
+              <a:t>13</a:t>
+            </a:fld>
+            <a:endParaRPr lang="en-US"/>
+          </a:p>
+        </p:txBody>
+      </p:sp>
+    </p:spTree>
+    <p:extLst>
+      <p:ext uri="{BB962C8B-B14F-4D97-AF65-F5344CB8AC3E}">
+        <p14:creationId xmlns:p14="http://schemas.microsoft.com/office/powerpoint/2010/main" val="1024086991"/>
+      </p:ext>
+    </p:extLst>
+  </p:cSld>
+  <p:clrMapOvr>
+    <a:masterClrMapping/>
+  </p:clrMapOvr>
+</p:notes>
+</file>
+
+<file path=ppt/notesSlides/notesSlide14.xml><?xml version="1.0" encoding="utf-8"?>
+<p:notes xmlns:a="http://schemas.openxmlformats.org/drawingml/2006/main" xmlns:r="http://schemas.openxmlformats.org/officeDocument/2006/relationships" xmlns:p="http://schemas.openxmlformats.org/presentationml/2006/main">
+  <p:cSld>
+    <p:spTree>
+      <p:nvGrpSpPr>
+        <p:cNvPr id="1" name=""/>
+        <p:cNvGrpSpPr/>
+        <p:nvPr/>
+      </p:nvGrpSpPr>
+      <p:grpSpPr>
+        <a:xfrm>
+          <a:off x="0" y="0"/>
+          <a:ext cx="0" cy="0"/>
+          <a:chOff x="0" y="0"/>
+          <a:chExt cx="0" cy="0"/>
+        </a:xfrm>
+      </p:grpSpPr>
+      <p:sp>
+        <p:nvSpPr>
+          <p:cNvPr id="2" name="Slide Image Placeholder 1"/>
+          <p:cNvSpPr>
+            <a:spLocks noGrp="1" noRot="1" noChangeAspect="1"/>
+          </p:cNvSpPr>
+          <p:nvPr>
+            <p:ph type="sldImg"/>
+          </p:nvPr>
+        </p:nvSpPr>
+        <p:spPr/>
+      </p:sp>
+      <p:sp>
+        <p:nvSpPr>
+          <p:cNvPr id="3" name="Notes Placeholder 2"/>
+          <p:cNvSpPr>
+            <a:spLocks noGrp="1"/>
+          </p:cNvSpPr>
+          <p:nvPr>
+            <p:ph type="body" idx="1"/>
+          </p:nvPr>
+        </p:nvSpPr>
+        <p:spPr/>
+        <p:txBody>
+          <a:bodyPr/>
+          <a:lstStyle/>
+          <a:p>
+            <a:r>
+              <a:rPr lang="en-US" dirty="0"/>
+              <a:t>Cerramos con dos frentes. Primero, reportes de nivel gerencial en tres pestañas, exportables a Excel y PDF para reuniones de directorio. Y segundo, confiabilidad: corregimos un caso en que dos áreas trabajando al mismo tiempo podían pisarse los cambios. Hoy el sistema garantiza que el estado final siempre sea el correcto, incluso bajo uso intenso.</a:t>
+            </a:r>
+            <a:endParaRPr lang="en-US" dirty="0"/>
+          </a:p>
+        </p:txBody>
+      </p:sp>
+      <p:sp>
+        <p:nvSpPr>
+          <p:cNvPr id="4" name="Slide Number Placeholder 3"/>
+          <p:cNvSpPr>
+            <a:spLocks noGrp="1"/>
+          </p:cNvSpPr>
+          <p:nvPr>
+            <p:ph type="sldNum" sz="quarter" idx="10"/>
+          </p:nvPr>
+        </p:nvSpPr>
+        <p:spPr/>
+        <p:txBody>
+          <a:bodyPr/>
+          <a:lstStyle/>
+          <a:p>
+            <a:fld id="{F7021451-1387-4CA6-816F-3879F97B5CBC}" type="slidenum">
+              <a:rPr lang="en-US"/>
+              <a:t>14</a:t>
+            </a:fld>
+            <a:endParaRPr lang="en-US"/>
+          </a:p>
+        </p:txBody>
+      </p:sp>
+    </p:spTree>
+    <p:extLst>
+      <p:ext uri="{BB962C8B-B14F-4D97-AF65-F5344CB8AC3E}">
+        <p14:creationId xmlns:p14="http://schemas.microsoft.com/office/powerpoint/2010/main" val="1024086991"/>
+      </p:ext>
+    </p:extLst>
+  </p:cSld>
+  <p:clrMapOvr>
+    <a:masterClrMapping/>
+  </p:clrMapOvr>
+</p:notes>
+</file>
+
+<file path=ppt/notesSlides/notesSlide15.xml><?xml version="1.0" encoding="utf-8"?>
+<p:notes xmlns:a="http://schemas.openxmlformats.org/drawingml/2006/main" xmlns:r="http://schemas.openxmlformats.org/officeDocument/2006/relationships" xmlns:p="http://schemas.openxmlformats.org/presentationml/2006/main">
+  <p:cSld>
+    <p:spTree>
+      <p:nvGrpSpPr>
+        <p:cNvPr id="1" name=""/>
+        <p:cNvGrpSpPr/>
+        <p:nvPr/>
+      </p:nvGrpSpPr>
+      <p:grpSpPr>
+        <a:xfrm>
+          <a:off x="0" y="0"/>
+          <a:ext cx="0" cy="0"/>
+          <a:chOff x="0" y="0"/>
+          <a:chExt cx="0" cy="0"/>
+        </a:xfrm>
+      </p:grpSpPr>
+      <p:sp>
+        <p:nvSpPr>
+          <p:cNvPr id="2" name="Slide Image Placeholder 1"/>
+          <p:cNvSpPr>
+            <a:spLocks noGrp="1" noRot="1" noChangeAspect="1"/>
+          </p:cNvSpPr>
+          <p:nvPr>
+            <p:ph type="sldImg"/>
+          </p:nvPr>
+        </p:nvSpPr>
+        <p:spPr/>
+      </p:sp>
+      <p:sp>
+        <p:nvSpPr>
+          <p:cNvPr id="3" name="Notes Placeholder 2"/>
+          <p:cNvSpPr>
+            <a:spLocks noGrp="1"/>
+          </p:cNvSpPr>
+          <p:nvPr>
+            <p:ph type="body" idx="1"/>
+          </p:nvPr>
+        </p:nvSpPr>
+        <p:spPr/>
+        <p:txBody>
+          <a:bodyPr/>
+          <a:lstStyle/>
+          <a:p>
+            <a:r>
+              <a:rPr lang="en-US" dirty="0"/>
+              <a:t>Gerente, el ERP ya está desplegado en producción, listo para ser adoptado por todos los jefes de área de la planta. Con su aprobación final para iniciar la capacitación y puesta en marcha, daremos el salto definitivo hacia la digitalización total de nuestra operación. Muchas gracias.</a:t>
+            </a:r>
+            <a:endParaRPr lang="en-US" dirty="0"/>
+          </a:p>
+        </p:txBody>
+      </p:sp>
+      <p:sp>
+        <p:nvSpPr>
+          <p:cNvPr id="4" name="Slide Number Placeholder 3"/>
+          <p:cNvSpPr>
+            <a:spLocks noGrp="1"/>
+          </p:cNvSpPr>
+          <p:nvPr>
+            <p:ph type="sldNum" sz="quarter" idx="10"/>
+          </p:nvPr>
+        </p:nvSpPr>
+        <p:spPr/>
+        <p:txBody>
+          <a:bodyPr/>
+          <a:lstStyle/>
+          <a:p>
+            <a:fld id="{F7021451-1387-4CA6-816F-3879F97B5CBC}" type="slidenum">
+              <a:rPr lang="en-US"/>
+              <a:t>15</a:t>
+            </a:fld>
+            <a:endParaRPr lang="en-US"/>
+          </a:p>
+        </p:txBody>
+      </p:sp>
+    </p:spTree>
+    <p:extLst>
+      <p:ext uri="{BB962C8B-B14F-4D97-AF65-F5344CB8AC3E}">
+        <p14:creationId xmlns:p14="http://schemas.microsoft.com/office/powerpoint/2010/main" val="1024086991"/>
+      </p:ext>
+    </p:extLst>
+  </p:cSld>
+  <p:clrMapOvr>
+    <a:masterClrMapping/>
+  </p:clrMapOvr>
+</p:notes>
+</file>
+
 <file path=ppt/notesSlides/notesSlide2.xml><?xml version="1.0" encoding="utf-8"?>
 <p:notes xmlns:a="http://schemas.openxmlformats.org/drawingml/2006/main" xmlns:r="http://schemas.openxmlformats.org/officeDocument/2006/relationships" xmlns:p="http://schemas.openxmlformats.org/presentationml/2006/main">
   <p:cSld>
@@ -1214,7 +1748,7 @@
           <a:p>
             <a:r>
               <a:rPr lang="en-US" dirty="0"/>
-              <a:t>Gerente, el ERP ya está desplegado en producción, listo para ser adoptado por todos los jefes de área de la planta. Con su aprobación final para iniciar la capacitación y puesta en marcha, daremos el salto definitivo hacia la digitalización total de nuestra operación. Muchas gracias.</a:t>
+              <a:t>Desde la última vez que les mostré el sistema, el foco de este ciclo fue uno solo: que la herramienta sea más fácil y útil en el día a día. No agregamos complejidad; agregamos claridad. Les muestro las cinco mejoras más importantes.</a:t>
             </a:r>
             <a:endParaRPr lang="en-US" dirty="0"/>
           </a:p>
@@ -1737,9 +2271,1834 @@
                 <a:ea typeface="Arial" pitchFamily="34" charset="-122"/>
                 <a:cs typeface="Arial" pitchFamily="34" charset="-120"/>
               </a:rPr>
-              <a:t>Presentación de Defensa del Proyecto · Junio 2026</a:t>
+              <a:t>Presentación de Defensa del Proyecto · Versión 2 (Junio 2026)</a:t>
             </a:r>
             <a:endParaRPr lang="en-US" sz="1200" dirty="0"/>
+          </a:p>
+        </p:txBody>
+      </p:sp>
+    </p:spTree>
+  </p:cSld>
+  <p:clrMapOvr>
+    <a:masterClrMapping/>
+  </p:clrMapOvr>
+</p:sld>
+</file>
+
+<file path=ppt/slides/slide10.xml><?xml version="1.0" encoding="utf-8"?>
+<p:sld xmlns:a="http://schemas.openxmlformats.org/drawingml/2006/main" xmlns:r="http://schemas.openxmlformats.org/officeDocument/2006/relationships" xmlns:p="http://schemas.openxmlformats.org/presentationml/2006/main">
+  <p:cSld name="Slide 10">
+    <p:bg>
+      <p:bgPr>
+        <a:solidFill>
+          <a:srgbClr val="060B18"/>
+        </a:solidFill>
+      </p:bgPr>
+    </p:bg>
+    <p:spTree>
+      <p:nvGrpSpPr>
+        <p:cNvPr id="1" name=""/>
+        <p:cNvGrpSpPr/>
+        <p:nvPr/>
+      </p:nvGrpSpPr>
+      <p:grpSpPr>
+        <a:xfrm>
+          <a:off x="0" y="0"/>
+          <a:ext cx="0" cy="0"/>
+          <a:chOff x="0" y="0"/>
+          <a:chExt cx="0" cy="0"/>
+        </a:xfrm>
+      </p:grpSpPr>
+      <p:sp>
+        <p:nvSpPr>
+          <p:cNvPr id="2" name="Text 0"/>
+          <p:cNvSpPr/>
+          <p:nvPr/>
+        </p:nvSpPr>
+        <p:spPr>
+          <a:xfrm>
+            <a:off x="548640" y="365760"/>
+            <a:ext cx="10972800" cy="731520"/>
+          </a:xfrm>
+          <a:prstGeom prst="rect">
+            <a:avLst/>
+          </a:prstGeom>
+          <a:noFill/>
+          <a:ln/>
+        </p:spPr>
+        <p:txBody>
+          <a:bodyPr wrap="square" rtlCol="0" anchor="ctr"/>
+          <a:lstStyle/>
+          <a:p>
+            <a:pPr indent="0" marL="0">
+              <a:buNone/>
+            </a:pPr>
+            <a:r>
+              <a:rPr lang="en-US" sz="2800" b="1" dirty="0">
+                <a:solidFill>
+                  <a:srgbClr val="EC9D2E"/>
+                </a:solidFill>
+                <a:latin typeface="Trebuchet MS" pitchFamily="34" charset="0"/>
+                <a:ea typeface="Trebuchet MS" pitchFamily="34" charset="-122"/>
+                <a:cs typeface="Trebuchet MS" pitchFamily="34" charset="-120"/>
+              </a:rPr>
+              <a:t>Inicio Rediseñado: el Tablero del Gerente</a:t>
+            </a:r>
+            <a:endParaRPr lang="en-US" sz="2800" dirty="0"/>
+          </a:p>
+        </p:txBody>
+      </p:sp>
+      <p:sp>
+        <p:nvSpPr>
+          <p:cNvPr id="3" name="Shape 1"/>
+          <p:cNvSpPr/>
+          <p:nvPr/>
+        </p:nvSpPr>
+        <p:spPr>
+          <a:xfrm>
+            <a:off x="548640" y="1005840"/>
+            <a:ext cx="10515600" cy="27432"/>
+          </a:xfrm>
+          <a:prstGeom prst="rect">
+            <a:avLst/>
+          </a:prstGeom>
+          <a:solidFill>
+            <a:srgbClr val="EC9D2E"/>
+          </a:solidFill>
+          <a:ln/>
+        </p:spPr>
+      </p:sp>
+      <p:sp>
+        <p:nvSpPr>
+          <p:cNvPr id="5" name="Shape 2"/>
+          <p:cNvSpPr/>
+          <p:nvPr/>
+        </p:nvSpPr>
+        <p:spPr>
+          <a:xfrm>
+            <a:off x="9784080" y="411480"/>
+            <a:ext cx="1737360" cy="457200"/>
+          </a:xfrm>
+          <a:prstGeom prst="roundRect">
+            <a:avLst>
+              <a:gd name="adj" fmla="val 20000"/>
+            </a:avLst>
+          </a:prstGeom>
+          <a:solidFill>
+            <a:srgbClr val="EC9D2E"/>
+          </a:solidFill>
+          <a:ln w="12700">
+            <a:solidFill>
+              <a:srgbClr val="EC9D2E"/>
+            </a:solidFill>
+            <a:prstDash val="solid"/>
+          </a:ln>
+        </p:spPr>
+      </p:sp>
+      <p:sp>
+        <p:nvSpPr>
+          <p:cNvPr id="6" name="Text 3"/>
+          <p:cNvSpPr/>
+          <p:nvPr/>
+        </p:nvSpPr>
+        <p:spPr>
+          <a:xfrm>
+            <a:off x="9784080" y="411480"/>
+            <a:ext cx="1737360" cy="457200"/>
+          </a:xfrm>
+          <a:prstGeom prst="rect">
+            <a:avLst/>
+          </a:prstGeom>
+          <a:noFill/>
+          <a:ln/>
+        </p:spPr>
+        <p:txBody>
+          <a:bodyPr wrap="square" rtlCol="0" anchor="ctr"/>
+          <a:lstStyle/>
+          <a:p>
+            <a:pPr algn="ctr" indent="0" marL="0">
+              <a:buNone/>
+            </a:pPr>
+            <a:r>
+              <a:rPr lang="en-US" sz="1300" b="1" dirty="0">
+                <a:solidFill>
+                  <a:srgbClr val="060B18"/>
+                </a:solidFill>
+                <a:latin typeface="Arial" pitchFamily="34" charset="0"/>
+                <a:ea typeface="Arial" pitchFamily="34" charset="-122"/>
+                <a:cs typeface="Arial" pitchFamily="34" charset="-120"/>
+              </a:rPr>
+              <a:t>NUEVO</a:t>
+            </a:r>
+            <a:endParaRPr lang="en-US" sz="1300" dirty="0"/>
+          </a:p>
+        </p:txBody>
+      </p:sp>
+      <p:sp>
+        <p:nvSpPr>
+          <p:cNvPr id="7" name="Text 4"/>
+          <p:cNvSpPr/>
+          <p:nvPr/>
+        </p:nvSpPr>
+        <p:spPr>
+          <a:xfrm>
+            <a:off x="731520" y="1371600"/>
+            <a:ext cx="10424160" cy="4389120"/>
+          </a:xfrm>
+          <a:prstGeom prst="rect">
+            <a:avLst/>
+          </a:prstGeom>
+          <a:noFill/>
+          <a:ln/>
+        </p:spPr>
+        <p:txBody>
+          <a:bodyPr wrap="square" rtlCol="0" anchor="ctr"/>
+          <a:lstStyle/>
+          <a:p>
+            <a:pPr indent="0" marL="0">
+              <a:lnSpc>
+                <a:spcPts val="2000"/>
+              </a:lnSpc>
+              <a:buNone/>
+            </a:pPr>
+            <a:r>
+              <a:rPr lang="en-US" sz="1500" dirty="0">
+                <a:solidFill>
+                  <a:srgbClr val="F8FAFC"/>
+                </a:solidFill>
+                <a:latin typeface="Arial" pitchFamily="34" charset="0"/>
+                <a:ea typeface="Arial" pitchFamily="34" charset="-122"/>
+                <a:cs typeface="Arial" pitchFamily="34" charset="-120"/>
+              </a:rPr>
+              <a:t>Rediseñamos la pantalla de inicio para que responda en 5 segundos las preguntas del gerente: </a:t>
+            </a:r>
+            <a:pPr indent="0" marL="0">
+              <a:lnSpc>
+                <a:spcPts val="2000"/>
+              </a:lnSpc>
+              <a:buNone/>
+            </a:pPr>
+            <a:r>
+              <a:rPr lang="en-US" sz="1500" b="1" dirty="0">
+                <a:solidFill>
+                  <a:srgbClr val="EC9D2E"/>
+                </a:solidFill>
+                <a:latin typeface="Arial" pitchFamily="34" charset="0"/>
+                <a:ea typeface="Arial" pitchFamily="34" charset="-122"/>
+                <a:cs typeface="Arial" pitchFamily="34" charset="-120"/>
+              </a:rPr>
+              <a:t>¿cuánta plata tengo en juego y cuánto falta cobrar? ¿qué se entrega pronto? ¿quién hizo qué?
+</a:t>
+            </a:r>
+            <a:pPr indent="0" marL="0">
+              <a:lnSpc>
+                <a:spcPts val="2000"/>
+              </a:lnSpc>
+              <a:buNone/>
+            </a:pPr>
+            <a:r>
+              <a:rPr lang="en-US" sz="1500" b="1" dirty="0">
+                <a:solidFill>
+                  <a:srgbClr val="EC9D2E"/>
+                </a:solidFill>
+                <a:latin typeface="Arial" pitchFamily="34" charset="0"/>
+                <a:ea typeface="Arial" pitchFamily="34" charset="-122"/>
+                <a:cs typeface="Arial" pitchFamily="34" charset="-120"/>
+              </a:rPr>
+              <a:t>• 4 indicadores de un vistazo: </a:t>
+            </a:r>
+            <a:pPr indent="0" marL="0">
+              <a:lnSpc>
+                <a:spcPts val="2000"/>
+              </a:lnSpc>
+              <a:buNone/>
+            </a:pPr>
+            <a:r>
+              <a:rPr lang="en-US" sz="1500" dirty="0">
+                <a:solidFill>
+                  <a:srgbClr val="F8FAFC"/>
+                </a:solidFill>
+                <a:latin typeface="Arial" pitchFamily="34" charset="0"/>
+                <a:ea typeface="Arial" pitchFamily="34" charset="-122"/>
+                <a:cs typeface="Arial" pitchFamily="34" charset="-120"/>
+              </a:rPr>
+              <a:t>Proyectos activos · Avance de producción · Plata en proyectos (cobrado vs. por cobrar) · Entregas y retrasos.
+</a:t>
+            </a:r>
+            <a:pPr indent="0" marL="0">
+              <a:lnSpc>
+                <a:spcPts val="2000"/>
+              </a:lnSpc>
+              <a:buNone/>
+            </a:pPr>
+            <a:r>
+              <a:rPr lang="en-US" sz="1500" b="1" dirty="0">
+                <a:solidFill>
+                  <a:srgbClr val="EC9D2E"/>
+                </a:solidFill>
+                <a:latin typeface="Arial" pitchFamily="34" charset="0"/>
+                <a:ea typeface="Arial" pitchFamily="34" charset="-122"/>
+                <a:cs typeface="Arial" pitchFamily="34" charset="-120"/>
+              </a:rPr>
+              <a:t>• Lenguaje de planta, no técnico: </a:t>
+            </a:r>
+            <a:pPr indent="0" marL="0">
+              <a:lnSpc>
+                <a:spcPts val="2000"/>
+              </a:lnSpc>
+              <a:buNone/>
+            </a:pPr>
+            <a:r>
+              <a:rPr lang="en-US" sz="1500" dirty="0">
+                <a:solidFill>
+                  <a:srgbClr val="F8FAFC"/>
+                </a:solidFill>
+                <a:latin typeface="Arial" pitchFamily="34" charset="0"/>
+                <a:ea typeface="Arial" pitchFamily="34" charset="-122"/>
+                <a:cs typeface="Arial" pitchFamily="34" charset="-120"/>
+              </a:rPr>
+              <a:t>"Lo que toca entregar pronto (los retrasados primero)", "¿En qué etapa está cada proyecto?".
+</a:t>
+            </a:r>
+            <a:pPr indent="0" marL="0">
+              <a:lnSpc>
+                <a:spcPts val="2000"/>
+              </a:lnSpc>
+              <a:buNone/>
+            </a:pPr>
+            <a:r>
+              <a:rPr lang="en-US" sz="1500" b="1" dirty="0">
+                <a:solidFill>
+                  <a:srgbClr val="EC9D2E"/>
+                </a:solidFill>
+                <a:latin typeface="Arial" pitchFamily="34" charset="0"/>
+                <a:ea typeface="Arial" pitchFamily="34" charset="-122"/>
+                <a:cs typeface="Arial" pitchFamily="34" charset="-120"/>
+              </a:rPr>
+              <a:t>• La tarjeta de retrasos se pinta de rojo sola </a:t>
+            </a:r>
+            <a:pPr indent="0" marL="0">
+              <a:lnSpc>
+                <a:spcPts val="2000"/>
+              </a:lnSpc>
+              <a:buNone/>
+            </a:pPr>
+            <a:r>
+              <a:rPr lang="en-US" sz="1500" dirty="0">
+                <a:solidFill>
+                  <a:srgbClr val="F8FAFC"/>
+                </a:solidFill>
+                <a:latin typeface="Arial" pitchFamily="34" charset="0"/>
+                <a:ea typeface="Arial" pitchFamily="34" charset="-122"/>
+                <a:cs typeface="Arial" pitchFamily="34" charset="-120"/>
+              </a:rPr>
+              <a:t>cuando hay proyectos vencidos: la gerencia ve el problema sin buscarlo.</a:t>
+            </a:r>
+            <a:endParaRPr lang="en-US" sz="1500" dirty="0"/>
+          </a:p>
+        </p:txBody>
+      </p:sp>
+    </p:spTree>
+  </p:cSld>
+  <p:clrMapOvr>
+    <a:masterClrMapping/>
+  </p:clrMapOvr>
+</p:sld>
+</file>
+
+<file path=ppt/slides/slide11.xml><?xml version="1.0" encoding="utf-8"?>
+<p:sld xmlns:a="http://schemas.openxmlformats.org/drawingml/2006/main" xmlns:r="http://schemas.openxmlformats.org/officeDocument/2006/relationships" xmlns:p="http://schemas.openxmlformats.org/presentationml/2006/main">
+  <p:cSld name="Slide 11">
+    <p:bg>
+      <p:bgPr>
+        <a:solidFill>
+          <a:srgbClr val="060B18"/>
+        </a:solidFill>
+      </p:bgPr>
+    </p:bg>
+    <p:spTree>
+      <p:nvGrpSpPr>
+        <p:cNvPr id="1" name=""/>
+        <p:cNvGrpSpPr/>
+        <p:nvPr/>
+      </p:nvGrpSpPr>
+      <p:grpSpPr>
+        <a:xfrm>
+          <a:off x="0" y="0"/>
+          <a:ext cx="0" cy="0"/>
+          <a:chOff x="0" y="0"/>
+          <a:chExt cx="0" cy="0"/>
+        </a:xfrm>
+      </p:grpSpPr>
+      <p:sp>
+        <p:nvSpPr>
+          <p:cNvPr id="2" name="Text 0"/>
+          <p:cNvSpPr/>
+          <p:nvPr/>
+        </p:nvSpPr>
+        <p:spPr>
+          <a:xfrm>
+            <a:off x="548640" y="365760"/>
+            <a:ext cx="10972800" cy="731520"/>
+          </a:xfrm>
+          <a:prstGeom prst="rect">
+            <a:avLst/>
+          </a:prstGeom>
+          <a:noFill/>
+          <a:ln/>
+        </p:spPr>
+        <p:txBody>
+          <a:bodyPr wrap="square" rtlCol="0" anchor="ctr"/>
+          <a:lstStyle/>
+          <a:p>
+            <a:pPr indent="0" marL="0">
+              <a:buNone/>
+            </a:pPr>
+            <a:r>
+              <a:rPr lang="en-US" sz="2800" b="1" dirty="0">
+                <a:solidFill>
+                  <a:srgbClr val="EC9D2E"/>
+                </a:solidFill>
+                <a:latin typeface="Trebuchet MS" pitchFamily="34" charset="0"/>
+                <a:ea typeface="Trebuchet MS" pitchFamily="34" charset="-122"/>
+                <a:cs typeface="Trebuchet MS" pitchFamily="34" charset="-120"/>
+              </a:rPr>
+              <a:t>Centro de Control en Vivo (Tiempo Real de Verdad)</a:t>
+            </a:r>
+            <a:endParaRPr lang="en-US" sz="2800" dirty="0"/>
+          </a:p>
+        </p:txBody>
+      </p:sp>
+      <p:sp>
+        <p:nvSpPr>
+          <p:cNvPr id="3" name="Shape 1"/>
+          <p:cNvSpPr/>
+          <p:nvPr/>
+        </p:nvSpPr>
+        <p:spPr>
+          <a:xfrm>
+            <a:off x="548640" y="1005840"/>
+            <a:ext cx="10515600" cy="27432"/>
+          </a:xfrm>
+          <a:prstGeom prst="rect">
+            <a:avLst/>
+          </a:prstGeom>
+          <a:solidFill>
+            <a:srgbClr val="EC9D2E"/>
+          </a:solidFill>
+          <a:ln/>
+        </p:spPr>
+      </p:sp>
+      <p:sp>
+        <p:nvSpPr>
+          <p:cNvPr id="5" name="Shape 2"/>
+          <p:cNvSpPr/>
+          <p:nvPr/>
+        </p:nvSpPr>
+        <p:spPr>
+          <a:xfrm>
+            <a:off x="9784080" y="411480"/>
+            <a:ext cx="1737360" cy="457200"/>
+          </a:xfrm>
+          <a:prstGeom prst="roundRect">
+            <a:avLst>
+              <a:gd name="adj" fmla="val 20000"/>
+            </a:avLst>
+          </a:prstGeom>
+          <a:solidFill>
+            <a:srgbClr val="EC9D2E"/>
+          </a:solidFill>
+          <a:ln w="12700">
+            <a:solidFill>
+              <a:srgbClr val="EC9D2E"/>
+            </a:solidFill>
+            <a:prstDash val="solid"/>
+          </a:ln>
+        </p:spPr>
+      </p:sp>
+      <p:sp>
+        <p:nvSpPr>
+          <p:cNvPr id="6" name="Text 3"/>
+          <p:cNvSpPr/>
+          <p:nvPr/>
+        </p:nvSpPr>
+        <p:spPr>
+          <a:xfrm>
+            <a:off x="9784080" y="411480"/>
+            <a:ext cx="1737360" cy="457200"/>
+          </a:xfrm>
+          <a:prstGeom prst="rect">
+            <a:avLst/>
+          </a:prstGeom>
+          <a:noFill/>
+          <a:ln/>
+        </p:spPr>
+        <p:txBody>
+          <a:bodyPr wrap="square" rtlCol="0" anchor="ctr"/>
+          <a:lstStyle/>
+          <a:p>
+            <a:pPr algn="ctr" indent="0" marL="0">
+              <a:buNone/>
+            </a:pPr>
+            <a:r>
+              <a:rPr lang="en-US" sz="1300" b="1" dirty="0">
+                <a:solidFill>
+                  <a:srgbClr val="060B18"/>
+                </a:solidFill>
+                <a:latin typeface="Arial" pitchFamily="34" charset="0"/>
+                <a:ea typeface="Arial" pitchFamily="34" charset="-122"/>
+                <a:cs typeface="Arial" pitchFamily="34" charset="-120"/>
+              </a:rPr>
+              <a:t>MEJORADO</a:t>
+            </a:r>
+            <a:endParaRPr lang="en-US" sz="1300" dirty="0"/>
+          </a:p>
+        </p:txBody>
+      </p:sp>
+      <p:sp>
+        <p:nvSpPr>
+          <p:cNvPr id="7" name="Text 4"/>
+          <p:cNvSpPr/>
+          <p:nvPr/>
+        </p:nvSpPr>
+        <p:spPr>
+          <a:xfrm>
+            <a:off x="731520" y="1371600"/>
+            <a:ext cx="10424160" cy="4389120"/>
+          </a:xfrm>
+          <a:prstGeom prst="rect">
+            <a:avLst/>
+          </a:prstGeom>
+          <a:noFill/>
+          <a:ln/>
+        </p:spPr>
+        <p:txBody>
+          <a:bodyPr wrap="square" rtlCol="0" anchor="ctr"/>
+          <a:lstStyle/>
+          <a:p>
+            <a:pPr indent="0" marL="0">
+              <a:lnSpc>
+                <a:spcPts val="2000"/>
+              </a:lnSpc>
+              <a:buNone/>
+            </a:pPr>
+            <a:r>
+              <a:rPr lang="en-US" sz="1500" dirty="0">
+                <a:solidFill>
+                  <a:srgbClr val="F8FAFC"/>
+                </a:solidFill>
+                <a:latin typeface="Arial" pitchFamily="34" charset="0"/>
+                <a:ea typeface="Arial" pitchFamily="34" charset="-122"/>
+                <a:cs typeface="Arial" pitchFamily="34" charset="-120"/>
+              </a:rPr>
+              <a:t>Antes el tablero se refrescaba cada 10 segundos. Ahora la actividad llega </a:t>
+            </a:r>
+            <a:pPr indent="0" marL="0">
+              <a:lnSpc>
+                <a:spcPts val="2000"/>
+              </a:lnSpc>
+              <a:buNone/>
+            </a:pPr>
+            <a:r>
+              <a:rPr lang="en-US" sz="1500" b="1" dirty="0">
+                <a:solidFill>
+                  <a:srgbClr val="EC9D2E"/>
+                </a:solidFill>
+                <a:latin typeface="Arial" pitchFamily="34" charset="0"/>
+                <a:ea typeface="Arial" pitchFamily="34" charset="-122"/>
+                <a:cs typeface="Arial" pitchFamily="34" charset="-120"/>
+              </a:rPr>
+              <a:t>al instante, empujada desde la base de datos</a:t>
+            </a:r>
+            <a:pPr indent="0" marL="0">
+              <a:lnSpc>
+                <a:spcPts val="2000"/>
+              </a:lnSpc>
+              <a:buNone/>
+            </a:pPr>
+            <a:r>
+              <a:rPr lang="en-US" sz="1500" dirty="0">
+                <a:solidFill>
+                  <a:srgbClr val="F8FAFC"/>
+                </a:solidFill>
+                <a:latin typeface="Arial" pitchFamily="34" charset="0"/>
+                <a:ea typeface="Arial" pitchFamily="34" charset="-122"/>
+                <a:cs typeface="Arial" pitchFamily="34" charset="-120"/>
+              </a:rPr>
+              <a:t> (WebSockets), con el refresco periódico solo como respaldo.
+</a:t>
+            </a:r>
+            <a:pPr indent="0" marL="0">
+              <a:lnSpc>
+                <a:spcPts val="2000"/>
+              </a:lnSpc>
+              <a:buNone/>
+            </a:pPr>
+            <a:r>
+              <a:rPr lang="en-US" sz="1500" b="1" dirty="0">
+                <a:solidFill>
+                  <a:srgbClr val="EC9D2E"/>
+                </a:solidFill>
+                <a:latin typeface="Arial" pitchFamily="34" charset="0"/>
+                <a:ea typeface="Arial" pitchFamily="34" charset="-122"/>
+                <a:cs typeface="Arial" pitchFamily="34" charset="-120"/>
+              </a:rPr>
+              <a:t>• Aviso imposible de ignorar: </a:t>
+            </a:r>
+            <a:pPr indent="0" marL="0">
+              <a:lnSpc>
+                <a:spcPts val="2000"/>
+              </a:lnSpc>
+              <a:buNone/>
+            </a:pPr>
+            <a:r>
+              <a:rPr lang="en-US" sz="1500" dirty="0">
+                <a:solidFill>
+                  <a:srgbClr val="F8FAFC"/>
+                </a:solidFill>
+                <a:latin typeface="Arial" pitchFamily="34" charset="0"/>
+                <a:ea typeface="Arial" pitchFamily="34" charset="-122"/>
+                <a:cs typeface="Arial" pitchFamily="34" charset="-120"/>
+              </a:rPr>
+              <a:t>cada acción nueva entra con un destello dorado y un sonido sutil de campana.
+</a:t>
+            </a:r>
+            <a:pPr indent="0" marL="0">
+              <a:lnSpc>
+                <a:spcPts val="2000"/>
+              </a:lnSpc>
+              <a:buNone/>
+            </a:pPr>
+            <a:r>
+              <a:rPr lang="en-US" sz="1500" b="1" dirty="0">
+                <a:solidFill>
+                  <a:srgbClr val="EC9D2E"/>
+                </a:solidFill>
+                <a:latin typeface="Arial" pitchFamily="34" charset="0"/>
+                <a:ea typeface="Arial" pitchFamily="34" charset="-122"/>
+                <a:cs typeface="Arial" pitchFamily="34" charset="-120"/>
+              </a:rPr>
+              <a:t>• Filtros instantáneos: </a:t>
+            </a:r>
+            <a:pPr indent="0" marL="0">
+              <a:lnSpc>
+                <a:spcPts val="2000"/>
+              </a:lnSpc>
+              <a:buNone/>
+            </a:pPr>
+            <a:r>
+              <a:rPr lang="en-US" sz="1500" dirty="0">
+                <a:solidFill>
+                  <a:srgbClr val="F8FAFC"/>
+                </a:solidFill>
+                <a:latin typeface="Arial" pitchFamily="34" charset="0"/>
+                <a:ea typeface="Arial" pitchFamily="34" charset="-122"/>
+                <a:cs typeface="Arial" pitchFamily="34" charset="-120"/>
+              </a:rPr>
+              <a:t>por área (Comercial, Ingeniería, Logística…), por tipo de acción (firmas, metrado, pagos, documentos) y búsqueda libre por usuario, cliente o PR.
+</a:t>
+            </a:r>
+            <a:pPr indent="0" marL="0">
+              <a:lnSpc>
+                <a:spcPts val="2000"/>
+              </a:lnSpc>
+              <a:buNone/>
+            </a:pPr>
+            <a:r>
+              <a:rPr lang="en-US" sz="1500" b="1" dirty="0">
+                <a:solidFill>
+                  <a:srgbClr val="EC9D2E"/>
+                </a:solidFill>
+                <a:latin typeface="Arial" pitchFamily="34" charset="0"/>
+                <a:ea typeface="Arial" pitchFamily="34" charset="-122"/>
+                <a:cs typeface="Arial" pitchFamily="34" charset="-120"/>
+              </a:rPr>
+              <a:t>• Tags clicables: </a:t>
+            </a:r>
+            <a:pPr indent="0" marL="0">
+              <a:lnSpc>
+                <a:spcPts val="2000"/>
+              </a:lnSpc>
+              <a:buNone/>
+            </a:pPr>
+            <a:r>
+              <a:rPr lang="en-US" sz="1500" dirty="0">
+                <a:solidFill>
+                  <a:srgbClr val="F8FAFC"/>
+                </a:solidFill>
+                <a:latin typeface="Arial" pitchFamily="34" charset="0"/>
+                <a:ea typeface="Arial" pitchFamily="34" charset="-122"/>
+                <a:cs typeface="Arial" pitchFamily="34" charset="-120"/>
+              </a:rPr>
+              <a:t>desde cualquier evento se salta directo al proyecto involucrado.</a:t>
+            </a:r>
+            <a:endParaRPr lang="en-US" sz="1500" dirty="0"/>
+          </a:p>
+        </p:txBody>
+      </p:sp>
+    </p:spTree>
+  </p:cSld>
+  <p:clrMapOvr>
+    <a:masterClrMapping/>
+  </p:clrMapOvr>
+</p:sld>
+</file>
+
+<file path=ppt/slides/slide12.xml><?xml version="1.0" encoding="utf-8"?>
+<p:sld xmlns:a="http://schemas.openxmlformats.org/drawingml/2006/main" xmlns:r="http://schemas.openxmlformats.org/officeDocument/2006/relationships" xmlns:p="http://schemas.openxmlformats.org/presentationml/2006/main">
+  <p:cSld name="Slide 12">
+    <p:bg>
+      <p:bgPr>
+        <a:solidFill>
+          <a:srgbClr val="060B18"/>
+        </a:solidFill>
+      </p:bgPr>
+    </p:bg>
+    <p:spTree>
+      <p:nvGrpSpPr>
+        <p:cNvPr id="1" name=""/>
+        <p:cNvGrpSpPr/>
+        <p:nvPr/>
+      </p:nvGrpSpPr>
+      <p:grpSpPr>
+        <a:xfrm>
+          <a:off x="0" y="0"/>
+          <a:ext cx="0" cy="0"/>
+          <a:chOff x="0" y="0"/>
+          <a:chExt cx="0" cy="0"/>
+        </a:xfrm>
+      </p:grpSpPr>
+      <p:sp>
+        <p:nvSpPr>
+          <p:cNvPr id="2" name="Text 0"/>
+          <p:cNvSpPr/>
+          <p:nvPr/>
+        </p:nvSpPr>
+        <p:spPr>
+          <a:xfrm>
+            <a:off x="548640" y="365760"/>
+            <a:ext cx="10972800" cy="731520"/>
+          </a:xfrm>
+          <a:prstGeom prst="rect">
+            <a:avLst/>
+          </a:prstGeom>
+          <a:noFill/>
+          <a:ln/>
+        </p:spPr>
+        <p:txBody>
+          <a:bodyPr wrap="square" rtlCol="0" anchor="ctr"/>
+          <a:lstStyle/>
+          <a:p>
+            <a:pPr indent="0" marL="0">
+              <a:buNone/>
+            </a:pPr>
+            <a:r>
+              <a:rPr lang="en-US" sz="2800" b="1" dirty="0">
+                <a:solidFill>
+                  <a:srgbClr val="EC9D2E"/>
+                </a:solidFill>
+                <a:latin typeface="Trebuchet MS" pitchFamily="34" charset="0"/>
+                <a:ea typeface="Trebuchet MS" pitchFamily="34" charset="-122"/>
+                <a:cs typeface="Trebuchet MS" pitchFamily="34" charset="-120"/>
+              </a:rPr>
+              <a:t>Alertas Automáticas de Vencimiento (Robot Diario)</a:t>
+            </a:r>
+            <a:endParaRPr lang="en-US" sz="2800" dirty="0"/>
+          </a:p>
+        </p:txBody>
+      </p:sp>
+      <p:sp>
+        <p:nvSpPr>
+          <p:cNvPr id="3" name="Shape 1"/>
+          <p:cNvSpPr/>
+          <p:nvPr/>
+        </p:nvSpPr>
+        <p:spPr>
+          <a:xfrm>
+            <a:off x="548640" y="1005840"/>
+            <a:ext cx="10515600" cy="27432"/>
+          </a:xfrm>
+          <a:prstGeom prst="rect">
+            <a:avLst/>
+          </a:prstGeom>
+          <a:solidFill>
+            <a:srgbClr val="EC9D2E"/>
+          </a:solidFill>
+          <a:ln/>
+        </p:spPr>
+      </p:sp>
+      <p:sp>
+        <p:nvSpPr>
+          <p:cNvPr id="5" name="Shape 2"/>
+          <p:cNvSpPr/>
+          <p:nvPr/>
+        </p:nvSpPr>
+        <p:spPr>
+          <a:xfrm>
+            <a:off x="9784080" y="411480"/>
+            <a:ext cx="1737360" cy="457200"/>
+          </a:xfrm>
+          <a:prstGeom prst="roundRect">
+            <a:avLst>
+              <a:gd name="adj" fmla="val 20000"/>
+            </a:avLst>
+          </a:prstGeom>
+          <a:solidFill>
+            <a:srgbClr val="EC9D2E"/>
+          </a:solidFill>
+          <a:ln w="12700">
+            <a:solidFill>
+              <a:srgbClr val="EC9D2E"/>
+            </a:solidFill>
+            <a:prstDash val="solid"/>
+          </a:ln>
+        </p:spPr>
+      </p:sp>
+      <p:sp>
+        <p:nvSpPr>
+          <p:cNvPr id="6" name="Text 3"/>
+          <p:cNvSpPr/>
+          <p:nvPr/>
+        </p:nvSpPr>
+        <p:spPr>
+          <a:xfrm>
+            <a:off x="9784080" y="411480"/>
+            <a:ext cx="1737360" cy="457200"/>
+          </a:xfrm>
+          <a:prstGeom prst="rect">
+            <a:avLst/>
+          </a:prstGeom>
+          <a:noFill/>
+          <a:ln/>
+        </p:spPr>
+        <p:txBody>
+          <a:bodyPr wrap="square" rtlCol="0" anchor="ctr"/>
+          <a:lstStyle/>
+          <a:p>
+            <a:pPr algn="ctr" indent="0" marL="0">
+              <a:buNone/>
+            </a:pPr>
+            <a:r>
+              <a:rPr lang="en-US" sz="1300" b="1" dirty="0">
+                <a:solidFill>
+                  <a:srgbClr val="060B18"/>
+                </a:solidFill>
+                <a:latin typeface="Arial" pitchFamily="34" charset="0"/>
+                <a:ea typeface="Arial" pitchFamily="34" charset="-122"/>
+                <a:cs typeface="Arial" pitchFamily="34" charset="-120"/>
+              </a:rPr>
+              <a:t>NUEVO</a:t>
+            </a:r>
+            <a:endParaRPr lang="en-US" sz="1300" dirty="0"/>
+          </a:p>
+        </p:txBody>
+      </p:sp>
+      <p:sp>
+        <p:nvSpPr>
+          <p:cNvPr id="7" name="Text 4"/>
+          <p:cNvSpPr/>
+          <p:nvPr/>
+        </p:nvSpPr>
+        <p:spPr>
+          <a:xfrm>
+            <a:off x="731520" y="1371600"/>
+            <a:ext cx="10424160" cy="4389120"/>
+          </a:xfrm>
+          <a:prstGeom prst="rect">
+            <a:avLst/>
+          </a:prstGeom>
+          <a:noFill/>
+          <a:ln/>
+        </p:spPr>
+        <p:txBody>
+          <a:bodyPr wrap="square" rtlCol="0" anchor="ctr"/>
+          <a:lstStyle/>
+          <a:p>
+            <a:pPr indent="0" marL="0">
+              <a:lnSpc>
+                <a:spcPts val="2000"/>
+              </a:lnSpc>
+              <a:buNone/>
+            </a:pPr>
+            <a:r>
+              <a:rPr lang="en-US" sz="1500" dirty="0">
+                <a:solidFill>
+                  <a:srgbClr val="F8FAFC"/>
+                </a:solidFill>
+                <a:latin typeface="Arial" pitchFamily="34" charset="0"/>
+                <a:ea typeface="Arial" pitchFamily="34" charset="-122"/>
+                <a:cs typeface="Arial" pitchFamily="34" charset="-120"/>
+              </a:rPr>
+              <a:t>El sistema ahora vigila los plazos por su cuenta. </a:t>
+            </a:r>
+            <a:pPr indent="0" marL="0">
+              <a:lnSpc>
+                <a:spcPts val="2000"/>
+              </a:lnSpc>
+              <a:buNone/>
+            </a:pPr>
+            <a:r>
+              <a:rPr lang="en-US" sz="1500" b="1" dirty="0">
+                <a:solidFill>
+                  <a:srgbClr val="EC9D2E"/>
+                </a:solidFill>
+                <a:latin typeface="Arial" pitchFamily="34" charset="0"/>
+                <a:ea typeface="Arial" pitchFamily="34" charset="-122"/>
+                <a:cs typeface="Arial" pitchFamily="34" charset="-120"/>
+              </a:rPr>
+              <a:t>Todos los días a las 8:00 a.m. (hora Lima)</a:t>
+            </a:r>
+            <a:pPr indent="0" marL="0">
+              <a:lnSpc>
+                <a:spcPts val="2000"/>
+              </a:lnSpc>
+              <a:buNone/>
+            </a:pPr>
+            <a:r>
+              <a:rPr lang="en-US" sz="1500" dirty="0">
+                <a:solidFill>
+                  <a:srgbClr val="F8FAFC"/>
+                </a:solidFill>
+                <a:latin typeface="Arial" pitchFamily="34" charset="0"/>
+                <a:ea typeface="Arial" pitchFamily="34" charset="-122"/>
+                <a:cs typeface="Arial" pitchFamily="34" charset="-120"/>
+              </a:rPr>
+              <a:t> un proceso automático revisa cada proyecto y avisa antes de que sea tarde.
+</a:t>
+            </a:r>
+            <a:pPr indent="0" marL="0">
+              <a:lnSpc>
+                <a:spcPts val="2000"/>
+              </a:lnSpc>
+              <a:buNone/>
+            </a:pPr>
+            <a:r>
+              <a:rPr lang="en-US" sz="1500" b="1" dirty="0">
+                <a:solidFill>
+                  <a:srgbClr val="EC9D2E"/>
+                </a:solidFill>
+                <a:latin typeface="Arial" pitchFamily="34" charset="0"/>
+                <a:ea typeface="Arial" pitchFamily="34" charset="-122"/>
+                <a:cs typeface="Arial" pitchFamily="34" charset="-120"/>
+              </a:rPr>
+              <a:t>• Avisa al área correcta: </a:t>
+            </a:r>
+            <a:pPr indent="0" marL="0">
+              <a:lnSpc>
+                <a:spcPts val="2000"/>
+              </a:lnSpc>
+              <a:buNone/>
+            </a:pPr>
+            <a:r>
+              <a:rPr lang="en-US" sz="1500" dirty="0">
+                <a:solidFill>
+                  <a:srgbClr val="F8FAFC"/>
+                </a:solidFill>
+                <a:latin typeface="Arial" pitchFamily="34" charset="0"/>
+                <a:ea typeface="Arial" pitchFamily="34" charset="-122"/>
+                <a:cs typeface="Arial" pitchFamily="34" charset="-120"/>
+              </a:rPr>
+              <a:t>la alerta llega al rol dueño de la etapa que está frenando el proyecto, no a todos por igual.
+</a:t>
+            </a:r>
+            <a:pPr indent="0" marL="0">
+              <a:lnSpc>
+                <a:spcPts val="2000"/>
+              </a:lnSpc>
+              <a:buNone/>
+            </a:pPr>
+            <a:r>
+              <a:rPr lang="en-US" sz="1500" b="1" dirty="0">
+                <a:solidFill>
+                  <a:srgbClr val="EC9D2E"/>
+                </a:solidFill>
+                <a:latin typeface="Arial" pitchFamily="34" charset="0"/>
+                <a:ea typeface="Arial" pitchFamily="34" charset="-122"/>
+                <a:cs typeface="Arial" pitchFamily="34" charset="-120"/>
+              </a:rPr>
+              <a:t>• Margen configurable: </a:t>
+            </a:r>
+            <a:pPr indent="0" marL="0">
+              <a:lnSpc>
+                <a:spcPts val="2000"/>
+              </a:lnSpc>
+              <a:buNone/>
+            </a:pPr>
+            <a:r>
+              <a:rPr lang="en-US" sz="1500" dirty="0">
+                <a:solidFill>
+                  <a:srgbClr val="F8FAFC"/>
+                </a:solidFill>
+                <a:latin typeface="Arial" pitchFamily="34" charset="0"/>
+                <a:ea typeface="Arial" pitchFamily="34" charset="-122"/>
+                <a:cs typeface="Arial" pitchFamily="34" charset="-120"/>
+              </a:rPr>
+              <a:t>desde Configuración se define con cuántos días de anticipación avisar (por defecto 7).
+</a:t>
+            </a:r>
+            <a:pPr indent="0" marL="0">
+              <a:lnSpc>
+                <a:spcPts val="2000"/>
+              </a:lnSpc>
+              <a:buNone/>
+            </a:pPr>
+            <a:r>
+              <a:rPr lang="en-US" sz="1500" b="1" dirty="0">
+                <a:solidFill>
+                  <a:srgbClr val="EC9D2E"/>
+                </a:solidFill>
+                <a:latin typeface="Arial" pitchFamily="34" charset="0"/>
+                <a:ea typeface="Arial" pitchFamily="34" charset="-122"/>
+                <a:cs typeface="Arial" pitchFamily="34" charset="-120"/>
+              </a:rPr>
+              <a:t>• Sin spam: </a:t>
+            </a:r>
+            <a:pPr indent="0" marL="0">
+              <a:lnSpc>
+                <a:spcPts val="2000"/>
+              </a:lnSpc>
+              <a:buNone/>
+            </a:pPr>
+            <a:r>
+              <a:rPr lang="en-US" sz="1500" dirty="0">
+                <a:solidFill>
+                  <a:srgbClr val="F8FAFC"/>
+                </a:solidFill>
+                <a:latin typeface="Arial" pitchFamily="34" charset="0"/>
+                <a:ea typeface="Arial" pitchFamily="34" charset="-122"/>
+                <a:cs typeface="Arial" pitchFamily="34" charset="-120"/>
+              </a:rPr>
+              <a:t>cada alerta se manda una sola vez. Si se reprograma la entrega, el sistema se reinicia y puede volver a avisar si vuelve a acercarse el plazo.</a:t>
+            </a:r>
+            <a:endParaRPr lang="en-US" sz="1500" dirty="0"/>
+          </a:p>
+        </p:txBody>
+      </p:sp>
+    </p:spTree>
+  </p:cSld>
+  <p:clrMapOvr>
+    <a:masterClrMapping/>
+  </p:clrMapOvr>
+</p:sld>
+</file>
+
+<file path=ppt/slides/slide13.xml><?xml version="1.0" encoding="utf-8"?>
+<p:sld xmlns:a="http://schemas.openxmlformats.org/drawingml/2006/main" xmlns:r="http://schemas.openxmlformats.org/officeDocument/2006/relationships" xmlns:p="http://schemas.openxmlformats.org/presentationml/2006/main">
+  <p:cSld name="Slide 13">
+    <p:bg>
+      <p:bgPr>
+        <a:solidFill>
+          <a:srgbClr val="060B18"/>
+        </a:solidFill>
+      </p:bgPr>
+    </p:bg>
+    <p:spTree>
+      <p:nvGrpSpPr>
+        <p:cNvPr id="1" name=""/>
+        <p:cNvGrpSpPr/>
+        <p:nvPr/>
+      </p:nvGrpSpPr>
+      <p:grpSpPr>
+        <a:xfrm>
+          <a:off x="0" y="0"/>
+          <a:ext cx="0" cy="0"/>
+          <a:chOff x="0" y="0"/>
+          <a:chExt cx="0" cy="0"/>
+        </a:xfrm>
+      </p:grpSpPr>
+      <p:sp>
+        <p:nvSpPr>
+          <p:cNvPr id="2" name="Text 0"/>
+          <p:cNvSpPr/>
+          <p:nvPr/>
+        </p:nvSpPr>
+        <p:spPr>
+          <a:xfrm>
+            <a:off x="548640" y="365760"/>
+            <a:ext cx="10972800" cy="731520"/>
+          </a:xfrm>
+          <a:prstGeom prst="rect">
+            <a:avLst/>
+          </a:prstGeom>
+          <a:noFill/>
+          <a:ln/>
+        </p:spPr>
+        <p:txBody>
+          <a:bodyPr wrap="square" rtlCol="0" anchor="ctr"/>
+          <a:lstStyle/>
+          <a:p>
+            <a:pPr indent="0" marL="0">
+              <a:buNone/>
+            </a:pPr>
+            <a:r>
+              <a:rPr lang="en-US" sz="2800" b="1" dirty="0">
+                <a:solidFill>
+                  <a:srgbClr val="EC9D2E"/>
+                </a:solidFill>
+                <a:latin typeface="Trebuchet MS" pitchFamily="34" charset="0"/>
+                <a:ea typeface="Trebuchet MS" pitchFamily="34" charset="-122"/>
+                <a:cs typeface="Trebuchet MS" pitchFamily="34" charset="-120"/>
+              </a:rPr>
+              <a:t>Productividad del Equipo (Avance, no Presencia)</a:t>
+            </a:r>
+            <a:endParaRPr lang="en-US" sz="2800" dirty="0"/>
+          </a:p>
+        </p:txBody>
+      </p:sp>
+      <p:sp>
+        <p:nvSpPr>
+          <p:cNvPr id="3" name="Shape 1"/>
+          <p:cNvSpPr/>
+          <p:nvPr/>
+        </p:nvSpPr>
+        <p:spPr>
+          <a:xfrm>
+            <a:off x="548640" y="1005840"/>
+            <a:ext cx="10515600" cy="27432"/>
+          </a:xfrm>
+          <a:prstGeom prst="rect">
+            <a:avLst/>
+          </a:prstGeom>
+          <a:solidFill>
+            <a:srgbClr val="EC9D2E"/>
+          </a:solidFill>
+          <a:ln/>
+        </p:spPr>
+      </p:sp>
+      <p:sp>
+        <p:nvSpPr>
+          <p:cNvPr id="5" name="Shape 2"/>
+          <p:cNvSpPr/>
+          <p:nvPr/>
+        </p:nvSpPr>
+        <p:spPr>
+          <a:xfrm>
+            <a:off x="9784080" y="411480"/>
+            <a:ext cx="1737360" cy="457200"/>
+          </a:xfrm>
+          <a:prstGeom prst="roundRect">
+            <a:avLst>
+              <a:gd name="adj" fmla="val 20000"/>
+            </a:avLst>
+          </a:prstGeom>
+          <a:solidFill>
+            <a:srgbClr val="EC9D2E"/>
+          </a:solidFill>
+          <a:ln w="12700">
+            <a:solidFill>
+              <a:srgbClr val="EC9D2E"/>
+            </a:solidFill>
+            <a:prstDash val="solid"/>
+          </a:ln>
+        </p:spPr>
+      </p:sp>
+      <p:sp>
+        <p:nvSpPr>
+          <p:cNvPr id="6" name="Text 3"/>
+          <p:cNvSpPr/>
+          <p:nvPr/>
+        </p:nvSpPr>
+        <p:spPr>
+          <a:xfrm>
+            <a:off x="9784080" y="411480"/>
+            <a:ext cx="1737360" cy="457200"/>
+          </a:xfrm>
+          <a:prstGeom prst="rect">
+            <a:avLst/>
+          </a:prstGeom>
+          <a:noFill/>
+          <a:ln/>
+        </p:spPr>
+        <p:txBody>
+          <a:bodyPr wrap="square" rtlCol="0" anchor="ctr"/>
+          <a:lstStyle/>
+          <a:p>
+            <a:pPr algn="ctr" indent="0" marL="0">
+              <a:buNone/>
+            </a:pPr>
+            <a:r>
+              <a:rPr lang="en-US" sz="1300" b="1" dirty="0">
+                <a:solidFill>
+                  <a:srgbClr val="060B18"/>
+                </a:solidFill>
+                <a:latin typeface="Arial" pitchFamily="34" charset="0"/>
+                <a:ea typeface="Arial" pitchFamily="34" charset="-122"/>
+                <a:cs typeface="Arial" pitchFamily="34" charset="-120"/>
+              </a:rPr>
+              <a:t>NUEVO</a:t>
+            </a:r>
+            <a:endParaRPr lang="en-US" sz="1300" dirty="0"/>
+          </a:p>
+        </p:txBody>
+      </p:sp>
+      <p:sp>
+        <p:nvSpPr>
+          <p:cNvPr id="7" name="Text 4"/>
+          <p:cNvSpPr/>
+          <p:nvPr/>
+        </p:nvSpPr>
+        <p:spPr>
+          <a:xfrm>
+            <a:off x="731520" y="1371600"/>
+            <a:ext cx="10424160" cy="4389120"/>
+          </a:xfrm>
+          <a:prstGeom prst="rect">
+            <a:avLst/>
+          </a:prstGeom>
+          <a:noFill/>
+          <a:ln/>
+        </p:spPr>
+        <p:txBody>
+          <a:bodyPr wrap="square" rtlCol="0" anchor="ctr"/>
+          <a:lstStyle/>
+          <a:p>
+            <a:pPr indent="0" marL="0">
+              <a:lnSpc>
+                <a:spcPts val="2000"/>
+              </a:lnSpc>
+              <a:buNone/>
+            </a:pPr>
+            <a:r>
+              <a:rPr lang="en-US" sz="1500" dirty="0">
+                <a:solidFill>
+                  <a:srgbClr val="F8FAFC"/>
+                </a:solidFill>
+                <a:latin typeface="Arial" pitchFamily="34" charset="0"/>
+                <a:ea typeface="Arial" pitchFamily="34" charset="-122"/>
+                <a:cs typeface="Arial" pitchFamily="34" charset="-120"/>
+              </a:rPr>
+              <a:t>Un panel nuevo que responde "¿quién está moviendo el trabajo?" midiendo </a:t>
+            </a:r>
+            <a:pPr indent="0" marL="0">
+              <a:lnSpc>
+                <a:spcPts val="2000"/>
+              </a:lnSpc>
+              <a:buNone/>
+            </a:pPr>
+            <a:r>
+              <a:rPr lang="en-US" sz="1500" b="1" dirty="0">
+                <a:solidFill>
+                  <a:srgbClr val="EC9D2E"/>
+                </a:solidFill>
+                <a:latin typeface="Arial" pitchFamily="34" charset="0"/>
+                <a:ea typeface="Arial" pitchFamily="34" charset="-122"/>
+                <a:cs typeface="Arial" pitchFamily="34" charset="-120"/>
+              </a:rPr>
+              <a:t>avance real, no horas frente a la pantalla.
+</a:t>
+            </a:r>
+            <a:pPr indent="0" marL="0">
+              <a:lnSpc>
+                <a:spcPts val="2000"/>
+              </a:lnSpc>
+              <a:buNone/>
+            </a:pPr>
+            <a:r>
+              <a:rPr lang="en-US" sz="1500" b="1" dirty="0">
+                <a:solidFill>
+                  <a:srgbClr val="EC9D2E"/>
+                </a:solidFill>
+                <a:latin typeface="Arial" pitchFamily="34" charset="0"/>
+                <a:ea typeface="Arial" pitchFamily="34" charset="-122"/>
+                <a:cs typeface="Arial" pitchFamily="34" charset="-120"/>
+              </a:rPr>
+              <a:t>• Hitos de valor vs. rutina: </a:t>
+            </a:r>
+            <a:pPr indent="0" marL="0">
+              <a:lnSpc>
+                <a:spcPts val="2000"/>
+              </a:lnSpc>
+              <a:buNone/>
+            </a:pPr>
+            <a:r>
+              <a:rPr lang="en-US" sz="1500" dirty="0">
+                <a:solidFill>
+                  <a:srgbClr val="F8FAFC"/>
+                </a:solidFill>
+                <a:latin typeface="Arial" pitchFamily="34" charset="0"/>
+                <a:ea typeface="Arial" pitchFamily="34" charset="-122"/>
+                <a:cs typeface="Arial" pitchFamily="34" charset="-120"/>
+              </a:rPr>
+              <a:t>separa las acciones que mueven la aguja (firmas de etapa, importar metrado, compras, avance de producción, crear proyectos, subir documentos) del trabajo rutinario.
+</a:t>
+            </a:r>
+            <a:pPr indent="0" marL="0">
+              <a:lnSpc>
+                <a:spcPts val="2000"/>
+              </a:lnSpc>
+              <a:buNone/>
+            </a:pPr>
+            <a:r>
+              <a:rPr lang="en-US" sz="1500" b="1" dirty="0">
+                <a:solidFill>
+                  <a:srgbClr val="EC9D2E"/>
+                </a:solidFill>
+                <a:latin typeface="Arial" pitchFamily="34" charset="0"/>
+                <a:ea typeface="Arial" pitchFamily="34" charset="-122"/>
+                <a:cs typeface="Arial" pitchFamily="34" charset="-120"/>
+              </a:rPr>
+              <a:t>• Detección de inactividad: </a:t>
+            </a:r>
+            <a:pPr indent="0" marL="0">
+              <a:lnSpc>
+                <a:spcPts val="2000"/>
+              </a:lnSpc>
+              <a:buNone/>
+            </a:pPr>
+            <a:r>
+              <a:rPr lang="en-US" sz="1500" dirty="0">
+                <a:solidFill>
+                  <a:srgbClr val="F8FAFC"/>
+                </a:solidFill>
+                <a:latin typeface="Arial" pitchFamily="34" charset="0"/>
+                <a:ea typeface="Arial" pitchFamily="34" charset="-122"/>
+                <a:cs typeface="Arial" pitchFamily="34" charset="-120"/>
+              </a:rPr>
+              <a:t>quien no registró movimientos en el período aparece marcado en rojo.
+</a:t>
+            </a:r>
+            <a:pPr indent="0" marL="0">
+              <a:lnSpc>
+                <a:spcPts val="2000"/>
+              </a:lnSpc>
+              <a:buNone/>
+            </a:pPr>
+            <a:r>
+              <a:rPr lang="en-US" sz="1500" b="1" dirty="0">
+                <a:solidFill>
+                  <a:srgbClr val="EC9D2E"/>
+                </a:solidFill>
+                <a:latin typeface="Arial" pitchFamily="34" charset="0"/>
+                <a:ea typeface="Arial" pitchFamily="34" charset="-122"/>
+                <a:cs typeface="Arial" pitchFamily="34" charset="-120"/>
+              </a:rPr>
+              <a:t>• Rangos rápidos: </a:t>
+            </a:r>
+            <a:pPr indent="0" marL="0">
+              <a:lnSpc>
+                <a:spcPts val="2000"/>
+              </a:lnSpc>
+              <a:buNone/>
+            </a:pPr>
+            <a:r>
+              <a:rPr lang="en-US" sz="1500" dirty="0">
+                <a:solidFill>
+                  <a:srgbClr val="F8FAFC"/>
+                </a:solidFill>
+                <a:latin typeface="Arial" pitchFamily="34" charset="0"/>
+                <a:ea typeface="Arial" pitchFamily="34" charset="-122"/>
+                <a:cs typeface="Arial" pitchFamily="34" charset="-120"/>
+              </a:rPr>
+              <a:t>Hoy · 7 días · 30 días, por persona y por área.</a:t>
+            </a:r>
+            <a:endParaRPr lang="en-US" sz="1500" dirty="0"/>
+          </a:p>
+        </p:txBody>
+      </p:sp>
+    </p:spTree>
+  </p:cSld>
+  <p:clrMapOvr>
+    <a:masterClrMapping/>
+  </p:clrMapOvr>
+</p:sld>
+</file>
+
+<file path=ppt/slides/slide14.xml><?xml version="1.0" encoding="utf-8"?>
+<p:sld xmlns:a="http://schemas.openxmlformats.org/drawingml/2006/main" xmlns:r="http://schemas.openxmlformats.org/officeDocument/2006/relationships" xmlns:p="http://schemas.openxmlformats.org/presentationml/2006/main">
+  <p:cSld name="Slide 14">
+    <p:bg>
+      <p:bgPr>
+        <a:solidFill>
+          <a:srgbClr val="060B18"/>
+        </a:solidFill>
+      </p:bgPr>
+    </p:bg>
+    <p:spTree>
+      <p:nvGrpSpPr>
+        <p:cNvPr id="1" name=""/>
+        <p:cNvGrpSpPr/>
+        <p:nvPr/>
+      </p:nvGrpSpPr>
+      <p:grpSpPr>
+        <a:xfrm>
+          <a:off x="0" y="0"/>
+          <a:ext cx="0" cy="0"/>
+          <a:chOff x="0" y="0"/>
+          <a:chExt cx="0" cy="0"/>
+        </a:xfrm>
+      </p:grpSpPr>
+      <p:sp>
+        <p:nvSpPr>
+          <p:cNvPr id="2" name="Text 0"/>
+          <p:cNvSpPr/>
+          <p:nvPr/>
+        </p:nvSpPr>
+        <p:spPr>
+          <a:xfrm>
+            <a:off x="548640" y="365760"/>
+            <a:ext cx="10972800" cy="731520"/>
+          </a:xfrm>
+          <a:prstGeom prst="rect">
+            <a:avLst/>
+          </a:prstGeom>
+          <a:noFill/>
+          <a:ln/>
+        </p:spPr>
+        <p:txBody>
+          <a:bodyPr wrap="square" rtlCol="0" anchor="ctr"/>
+          <a:lstStyle/>
+          <a:p>
+            <a:pPr indent="0" marL="0">
+              <a:buNone/>
+            </a:pPr>
+            <a:r>
+              <a:rPr lang="en-US" sz="2800" b="1" dirty="0">
+                <a:solidFill>
+                  <a:srgbClr val="EC9D2E"/>
+                </a:solidFill>
+                <a:latin typeface="Trebuchet MS" pitchFamily="34" charset="0"/>
+                <a:ea typeface="Trebuchet MS" pitchFamily="34" charset="-122"/>
+                <a:cs typeface="Trebuchet MS" pitchFamily="34" charset="-120"/>
+              </a:rPr>
+              <a:t>Reportes Ejecutivos y Mayor Confiabilidad</a:t>
+            </a:r>
+            <a:endParaRPr lang="en-US" sz="2800" dirty="0"/>
+          </a:p>
+        </p:txBody>
+      </p:sp>
+      <p:sp>
+        <p:nvSpPr>
+          <p:cNvPr id="3" name="Shape 1"/>
+          <p:cNvSpPr/>
+          <p:nvPr/>
+        </p:nvSpPr>
+        <p:spPr>
+          <a:xfrm>
+            <a:off x="548640" y="1005840"/>
+            <a:ext cx="10515600" cy="27432"/>
+          </a:xfrm>
+          <a:prstGeom prst="rect">
+            <a:avLst/>
+          </a:prstGeom>
+          <a:solidFill>
+            <a:srgbClr val="EC9D2E"/>
+          </a:solidFill>
+          <a:ln/>
+        </p:spPr>
+      </p:sp>
+      <p:sp>
+        <p:nvSpPr>
+          <p:cNvPr id="5" name="Shape 2"/>
+          <p:cNvSpPr/>
+          <p:nvPr/>
+        </p:nvSpPr>
+        <p:spPr>
+          <a:xfrm>
+            <a:off x="9784080" y="411480"/>
+            <a:ext cx="1737360" cy="457200"/>
+          </a:xfrm>
+          <a:prstGeom prst="roundRect">
+            <a:avLst>
+              <a:gd name="adj" fmla="val 20000"/>
+            </a:avLst>
+          </a:prstGeom>
+          <a:solidFill>
+            <a:srgbClr val="EC9D2E"/>
+          </a:solidFill>
+          <a:ln w="12700">
+            <a:solidFill>
+              <a:srgbClr val="EC9D2E"/>
+            </a:solidFill>
+            <a:prstDash val="solid"/>
+          </a:ln>
+        </p:spPr>
+      </p:sp>
+      <p:sp>
+        <p:nvSpPr>
+          <p:cNvPr id="6" name="Text 3"/>
+          <p:cNvSpPr/>
+          <p:nvPr/>
+        </p:nvSpPr>
+        <p:spPr>
+          <a:xfrm>
+            <a:off x="9784080" y="411480"/>
+            <a:ext cx="1737360" cy="457200"/>
+          </a:xfrm>
+          <a:prstGeom prst="rect">
+            <a:avLst/>
+          </a:prstGeom>
+          <a:noFill/>
+          <a:ln/>
+        </p:spPr>
+        <p:txBody>
+          <a:bodyPr wrap="square" rtlCol="0" anchor="ctr"/>
+          <a:lstStyle/>
+          <a:p>
+            <a:pPr algn="ctr" indent="0" marL="0">
+              <a:buNone/>
+            </a:pPr>
+            <a:r>
+              <a:rPr lang="en-US" sz="1300" b="1" dirty="0">
+                <a:solidFill>
+                  <a:srgbClr val="060B18"/>
+                </a:solidFill>
+                <a:latin typeface="Arial" pitchFamily="34" charset="0"/>
+                <a:ea typeface="Arial" pitchFamily="34" charset="-122"/>
+                <a:cs typeface="Arial" pitchFamily="34" charset="-120"/>
+              </a:rPr>
+              <a:t>MEJORADO</a:t>
+            </a:r>
+            <a:endParaRPr lang="en-US" sz="1300" dirty="0"/>
+          </a:p>
+        </p:txBody>
+      </p:sp>
+      <p:sp>
+        <p:nvSpPr>
+          <p:cNvPr id="7" name="Text 4"/>
+          <p:cNvSpPr/>
+          <p:nvPr/>
+        </p:nvSpPr>
+        <p:spPr>
+          <a:xfrm>
+            <a:off x="731520" y="1371600"/>
+            <a:ext cx="10424160" cy="4389120"/>
+          </a:xfrm>
+          <a:prstGeom prst="rect">
+            <a:avLst/>
+          </a:prstGeom>
+          <a:noFill/>
+          <a:ln/>
+        </p:spPr>
+        <p:txBody>
+          <a:bodyPr wrap="square" rtlCol="0" anchor="ctr"/>
+          <a:lstStyle/>
+          <a:p>
+            <a:pPr indent="0" marL="0">
+              <a:lnSpc>
+                <a:spcPts val="2000"/>
+              </a:lnSpc>
+              <a:buNone/>
+            </a:pPr>
+            <a:r>
+              <a:rPr lang="en-US" sz="1500" b="1" dirty="0">
+                <a:solidFill>
+                  <a:srgbClr val="EC9D2E"/>
+                </a:solidFill>
+                <a:latin typeface="Arial" pitchFamily="34" charset="0"/>
+                <a:ea typeface="Arial" pitchFamily="34" charset="-122"/>
+                <a:cs typeface="Arial" pitchFamily="34" charset="-120"/>
+              </a:rPr>
+              <a:t>• Reportes en 3 pestañas: </a:t>
+            </a:r>
+            <a:pPr indent="0" marL="0">
+              <a:lnSpc>
+                <a:spcPts val="2000"/>
+              </a:lnSpc>
+              <a:buNone/>
+            </a:pPr>
+            <a:r>
+              <a:rPr lang="en-US" sz="1500" dirty="0">
+                <a:solidFill>
+                  <a:srgbClr val="F8FAFC"/>
+                </a:solidFill>
+                <a:latin typeface="Arial" pitchFamily="34" charset="0"/>
+                <a:ea typeface="Arial" pitchFamily="34" charset="-122"/>
+                <a:cs typeface="Arial" pitchFamily="34" charset="-120"/>
+              </a:rPr>
+              <a:t>General (estado y avance), Financiero (montos, cobrado, por cobrar) y Responsables (rendimiento por persona), con filtros y exportación a Excel y PDF.
+</a:t>
+            </a:r>
+            <a:pPr indent="0" marL="0">
+              <a:lnSpc>
+                <a:spcPts val="2000"/>
+              </a:lnSpc>
+              <a:buNone/>
+            </a:pPr>
+            <a:r>
+              <a:rPr lang="en-US" sz="1500" b="1" dirty="0">
+                <a:solidFill>
+                  <a:srgbClr val="EC9D2E"/>
+                </a:solidFill>
+                <a:latin typeface="Arial" pitchFamily="34" charset="0"/>
+                <a:ea typeface="Arial" pitchFamily="34" charset="-122"/>
+                <a:cs typeface="Arial" pitchFamily="34" charset="-120"/>
+              </a:rPr>
+              <a:t>• Interfaz más limpia: </a:t>
+            </a:r>
+            <a:pPr indent="0" marL="0">
+              <a:lnSpc>
+                <a:spcPts val="2000"/>
+              </a:lnSpc>
+              <a:buNone/>
+            </a:pPr>
+            <a:r>
+              <a:rPr lang="en-US" sz="1500" dirty="0">
+                <a:solidFill>
+                  <a:srgbClr val="F8FAFC"/>
+                </a:solidFill>
+                <a:latin typeface="Arial" pitchFamily="34" charset="0"/>
+                <a:ea typeface="Arial" pitchFamily="34" charset="-122"/>
+                <a:cs typeface="Arial" pitchFamily="34" charset="-120"/>
+              </a:rPr>
+              <a:t>consolidamos el menú lateral y quitamos pantallas sueltas para que nadie se pierda.
+</a:t>
+            </a:r>
+            <a:pPr indent="0" marL="0">
+              <a:lnSpc>
+                <a:spcPts val="2000"/>
+              </a:lnSpc>
+              <a:buNone/>
+            </a:pPr>
+            <a:r>
+              <a:rPr lang="en-US" sz="1500" b="1" dirty="0">
+                <a:solidFill>
+                  <a:srgbClr val="EC9D2E"/>
+                </a:solidFill>
+                <a:latin typeface="Arial" pitchFamily="34" charset="0"/>
+                <a:ea typeface="Arial" pitchFamily="34" charset="-122"/>
+                <a:cs typeface="Arial" pitchFamily="34" charset="-120"/>
+              </a:rPr>
+              <a:t>• Confiabilidad bajo presión: </a:t>
+            </a:r>
+            <a:pPr indent="0" marL="0">
+              <a:lnSpc>
+                <a:spcPts val="2000"/>
+              </a:lnSpc>
+              <a:buNone/>
+            </a:pPr>
+            <a:r>
+              <a:rPr lang="en-US" sz="1500" dirty="0">
+                <a:solidFill>
+                  <a:srgbClr val="F8FAFC"/>
+                </a:solidFill>
+                <a:latin typeface="Arial" pitchFamily="34" charset="0"/>
+                <a:ea typeface="Arial" pitchFamily="34" charset="-122"/>
+                <a:cs typeface="Arial" pitchFamily="34" charset="-120"/>
+              </a:rPr>
+              <a:t>corregimos una condición de carrera que podía sobrescribir cambios cuando dos áreas trabajaban a la vez. Hoy el último estado siempre es el correcto.
+</a:t>
+            </a:r>
+            <a:pPr indent="0" marL="0">
+              <a:lnSpc>
+                <a:spcPts val="2000"/>
+              </a:lnSpc>
+              <a:buNone/>
+            </a:pPr>
+            <a:r>
+              <a:rPr lang="en-US" sz="1500" b="1" dirty="0">
+                <a:solidFill>
+                  <a:srgbClr val="EC9D2E"/>
+                </a:solidFill>
+                <a:latin typeface="Arial" pitchFamily="34" charset="0"/>
+                <a:ea typeface="Arial" pitchFamily="34" charset="-122"/>
+                <a:cs typeface="Arial" pitchFamily="34" charset="-120"/>
+              </a:rPr>
+              <a:t>• Validaciones y avisos cruzados: </a:t>
+            </a:r>
+            <a:pPr indent="0" marL="0">
+              <a:lnSpc>
+                <a:spcPts val="2000"/>
+              </a:lnSpc>
+              <a:buNone/>
+            </a:pPr>
+            <a:r>
+              <a:rPr lang="en-US" sz="1500" dirty="0">
+                <a:solidFill>
+                  <a:srgbClr val="F8FAFC"/>
+                </a:solidFill>
+                <a:latin typeface="Arial" pitchFamily="34" charset="0"/>
+                <a:ea typeface="Arial" pitchFamily="34" charset="-122"/>
+                <a:cs typeface="Arial" pitchFamily="34" charset="-120"/>
+              </a:rPr>
+              <a:t>plazos sin valores negativos, y Logística se entera del metrado aunque lo cargue un administrador.</a:t>
+            </a:r>
+            <a:endParaRPr lang="en-US" sz="1500" dirty="0"/>
+          </a:p>
+        </p:txBody>
+      </p:sp>
+    </p:spTree>
+  </p:cSld>
+  <p:clrMapOvr>
+    <a:masterClrMapping/>
+  </p:clrMapOvr>
+</p:sld>
+</file>
+
+<file path=ppt/slides/slide15.xml><?xml version="1.0" encoding="utf-8"?>
+<p:sld xmlns:a="http://schemas.openxmlformats.org/drawingml/2006/main" xmlns:r="http://schemas.openxmlformats.org/officeDocument/2006/relationships" xmlns:p="http://schemas.openxmlformats.org/presentationml/2006/main">
+  <p:cSld name="Slide 15">
+    <p:bg>
+      <p:bgPr>
+        <a:solidFill>
+          <a:srgbClr val="060B18"/>
+        </a:solidFill>
+      </p:bgPr>
+    </p:bg>
+    <p:spTree>
+      <p:nvGrpSpPr>
+        <p:cNvPr id="1" name=""/>
+        <p:cNvGrpSpPr/>
+        <p:nvPr/>
+      </p:nvGrpSpPr>
+      <p:grpSpPr>
+        <a:xfrm>
+          <a:off x="0" y="0"/>
+          <a:ext cx="0" cy="0"/>
+          <a:chOff x="0" y="0"/>
+          <a:chExt cx="0" cy="0"/>
+        </a:xfrm>
+      </p:grpSpPr>
+      <p:sp>
+        <p:nvSpPr>
+          <p:cNvPr id="2" name="Text 0"/>
+          <p:cNvSpPr/>
+          <p:nvPr/>
+        </p:nvSpPr>
+        <p:spPr>
+          <a:xfrm>
+            <a:off x="914400" y="1645920"/>
+            <a:ext cx="10332720" cy="914400"/>
+          </a:xfrm>
+          <a:prstGeom prst="rect">
+            <a:avLst/>
+          </a:prstGeom>
+          <a:noFill/>
+          <a:ln/>
+        </p:spPr>
+        <p:txBody>
+          <a:bodyPr wrap="square" rtlCol="0" anchor="ctr"/>
+          <a:lstStyle/>
+          <a:p>
+            <a:pPr indent="0" marL="0">
+              <a:buNone/>
+            </a:pPr>
+            <a:r>
+              <a:rPr lang="en-US" sz="3600" b="1" dirty="0">
+                <a:solidFill>
+                  <a:srgbClr val="EC9D2E"/>
+                </a:solidFill>
+                <a:latin typeface="Trebuchet MS" pitchFamily="34" charset="0"/>
+                <a:ea typeface="Trebuchet MS" pitchFamily="34" charset="-122"/>
+                <a:cs typeface="Trebuchet MS" pitchFamily="34" charset="-120"/>
+              </a:rPr>
+              <a:t>El Futuro de Nuestra Operación Comienza Hoy</a:t>
+            </a:r>
+            <a:endParaRPr lang="en-US" sz="3600" dirty="0"/>
+          </a:p>
+        </p:txBody>
+      </p:sp>
+      <p:sp>
+        <p:nvSpPr>
+          <p:cNvPr id="3" name="Text 1"/>
+          <p:cNvSpPr/>
+          <p:nvPr/>
+        </p:nvSpPr>
+        <p:spPr>
+          <a:xfrm>
+            <a:off x="914400" y="2743200"/>
+            <a:ext cx="9601200" cy="1371600"/>
+          </a:xfrm>
+          <a:prstGeom prst="rect">
+            <a:avLst/>
+          </a:prstGeom>
+          <a:noFill/>
+          <a:ln/>
+        </p:spPr>
+        <p:txBody>
+          <a:bodyPr wrap="square" rtlCol="0" anchor="ctr"/>
+          <a:lstStyle/>
+          <a:p>
+            <a:pPr indent="0" marL="0">
+              <a:lnSpc>
+                <a:spcPts val="2800"/>
+              </a:lnSpc>
+              <a:buNone/>
+            </a:pPr>
+            <a:r>
+              <a:rPr lang="en-US" sz="1800" dirty="0">
+                <a:solidFill>
+                  <a:srgbClr val="F8FAFC"/>
+                </a:solidFill>
+                <a:latin typeface="Arial" pitchFamily="34" charset="0"/>
+                <a:ea typeface="Arial" pitchFamily="34" charset="-122"/>
+                <a:cs typeface="Arial" pitchFamily="34" charset="-120"/>
+              </a:rPr>
+              <a:t>Con BBTI ERP, consolidamos una </a:t>
+            </a:r>
+            <a:pPr indent="0" marL="0">
+              <a:lnSpc>
+                <a:spcPts val="2800"/>
+              </a:lnSpc>
+              <a:buNone/>
+            </a:pPr>
+            <a:r>
+              <a:rPr lang="en-US" sz="1800" b="1" dirty="0">
+                <a:solidFill>
+                  <a:srgbClr val="EC9D2E"/>
+                </a:solidFill>
+                <a:latin typeface="Arial" pitchFamily="34" charset="0"/>
+                <a:ea typeface="Arial" pitchFamily="34" charset="-122"/>
+                <a:cs typeface="Arial" pitchFamily="34" charset="-120"/>
+              </a:rPr>
+              <a:t>planta conectada, transparente y eficiente</a:t>
+            </a:r>
+            <a:pPr indent="0" marL="0">
+              <a:lnSpc>
+                <a:spcPts val="2800"/>
+              </a:lnSpc>
+              <a:buNone/>
+            </a:pPr>
+            <a:r>
+              <a:rPr lang="en-US" sz="1800" dirty="0">
+                <a:solidFill>
+                  <a:srgbClr val="F8FAFC"/>
+                </a:solidFill>
+                <a:latin typeface="Arial" pitchFamily="34" charset="0"/>
+                <a:ea typeface="Arial" pitchFamily="34" charset="-122"/>
+                <a:cs typeface="Arial" pitchFamily="34" charset="-120"/>
+              </a:rPr>
+              <a:t>. Reducimos costos, delimitamos responsabilidades y brindamos a la gerencia la tranquilidad de tener el control total al alcance de su mano.</a:t>
+            </a:r>
+            <a:endParaRPr lang="en-US" sz="1800" dirty="0"/>
+          </a:p>
+        </p:txBody>
+      </p:sp>
+      <p:sp>
+        <p:nvSpPr>
+          <p:cNvPr id="4" name="Text 2"/>
+          <p:cNvSpPr/>
+          <p:nvPr/>
+        </p:nvSpPr>
+        <p:spPr>
+          <a:xfrm>
+            <a:off x="914400" y="4389120"/>
+            <a:ext cx="10332720" cy="548640"/>
+          </a:xfrm>
+          <a:prstGeom prst="rect">
+            <a:avLst/>
+          </a:prstGeom>
+          <a:noFill/>
+          <a:ln/>
+        </p:spPr>
+        <p:txBody>
+          <a:bodyPr wrap="square" rtlCol="0" anchor="ctr"/>
+          <a:lstStyle/>
+          <a:p>
+            <a:pPr indent="0" marL="0">
+              <a:buNone/>
+            </a:pPr>
+            <a:r>
+              <a:rPr lang="en-US" sz="2000" b="1" dirty="0">
+                <a:solidFill>
+                  <a:srgbClr val="EC9D2E"/>
+                </a:solidFill>
+                <a:latin typeface="Arial" pitchFamily="34" charset="0"/>
+                <a:ea typeface="Arial" pitchFamily="34" charset="-122"/>
+                <a:cs typeface="Arial" pitchFamily="34" charset="-120"/>
+              </a:rPr>
+              <a:t>Muchas Gracias. ¿Preguntas?</a:t>
+            </a:r>
+            <a:endParaRPr lang="en-US" sz="2000" dirty="0"/>
           </a:p>
         </p:txBody>
       </p:sp>
@@ -1829,7 +4188,7 @@
             <a:avLst/>
           </a:prstGeom>
           <a:solidFill>
-            <a:srgbClr val="000000"/>
+            <a:srgbClr val="EC9D2E"/>
           </a:solidFill>
           <a:ln/>
         </p:spPr>
@@ -2084,7 +4443,7 @@
             <a:avLst/>
           </a:prstGeom>
           <a:solidFill>
-            <a:srgbClr val="000000"/>
+            <a:srgbClr val="EC9D2E"/>
           </a:solidFill>
           <a:ln/>
         </p:spPr>
@@ -2104,7 +4463,7 @@
             <a:avLst/>
           </a:prstGeom>
           <a:solidFill>
-            <a:srgbClr val="000000"/>
+            <a:srgbClr val="255468"/>
           </a:solidFill>
           <a:ln w="12700">
             <a:solidFill>
@@ -2198,7 +4557,7 @@
             <a:avLst/>
           </a:prstGeom>
           <a:solidFill>
-            <a:srgbClr val="000000"/>
+            <a:srgbClr val="255468"/>
           </a:solidFill>
           <a:ln w="12700">
             <a:solidFill>
@@ -2292,7 +4651,7 @@
             <a:avLst/>
           </a:prstGeom>
           <a:solidFill>
-            <a:srgbClr val="000000"/>
+            <a:srgbClr val="255468"/>
           </a:solidFill>
           <a:ln w="12700">
             <a:solidFill>
@@ -2386,7 +4745,7 @@
             <a:avLst/>
           </a:prstGeom>
           <a:solidFill>
-            <a:srgbClr val="000000"/>
+            <a:srgbClr val="255468"/>
           </a:solidFill>
           <a:ln w="12700">
             <a:solidFill>
@@ -2551,7 +4910,7 @@
             <a:avLst/>
           </a:prstGeom>
           <a:solidFill>
-            <a:srgbClr val="000000"/>
+            <a:srgbClr val="EC9D2E"/>
           </a:solidFill>
           <a:ln/>
         </p:spPr>
@@ -2808,7 +5167,7 @@
             <a:avLst/>
           </a:prstGeom>
           <a:solidFill>
-            <a:srgbClr val="000000"/>
+            <a:srgbClr val="EC9D2E"/>
           </a:solidFill>
           <a:ln/>
         </p:spPr>
@@ -3083,7 +5442,7 @@
             <a:avLst/>
           </a:prstGeom>
           <a:solidFill>
-            <a:srgbClr val="000000"/>
+            <a:srgbClr val="EC9D2E"/>
           </a:solidFill>
           <a:ln/>
         </p:spPr>
@@ -3357,7 +5716,7 @@
             <a:avLst/>
           </a:prstGeom>
           <a:solidFill>
-            <a:srgbClr val="000000"/>
+            <a:srgbClr val="EC9D2E"/>
           </a:solidFill>
           <a:ln/>
         </p:spPr>
@@ -3596,7 +5955,7 @@
             <a:avLst/>
           </a:prstGeom>
           <a:solidFill>
-            <a:srgbClr val="000000"/>
+            <a:srgbClr val="EC9D2E"/>
           </a:solidFill>
           <a:ln/>
         </p:spPr>
@@ -3616,7 +5975,7 @@
             <a:avLst/>
           </a:prstGeom>
           <a:solidFill>
-            <a:srgbClr val="000000"/>
+            <a:srgbClr val="255468"/>
           </a:solidFill>
           <a:ln w="25400">
             <a:solidFill>
@@ -3719,7 +6078,7 @@
             <a:avLst/>
           </a:prstGeom>
           <a:solidFill>
-            <a:srgbClr val="000000"/>
+            <a:srgbClr val="255468"/>
           </a:solidFill>
           <a:ln w="25400">
             <a:solidFill>
@@ -3822,7 +6181,7 @@
             <a:avLst/>
           </a:prstGeom>
           <a:solidFill>
-            <a:srgbClr val="000000"/>
+            <a:srgbClr val="255468"/>
           </a:solidFill>
           <a:ln w="25400">
             <a:solidFill>
@@ -3943,7 +6302,7 @@
                 <a:ea typeface="Arial" pitchFamily="34" charset="-122"/>
                 <a:cs typeface="Arial" pitchFamily="34" charset="-120"/>
               </a:rPr>
-              <a:t>➔ Mayor control de planta · ➔ Eliminación de cuellos de botella · ➔ Decisiones basadas en datos</a:t>
+              <a:t>➔ Mayor control de planta · ➔ Alertas que se adelantan a los retrasos · ➔ Decisiones basadas en datos</a:t>
             </a:r>
             <a:endParaRPr lang="en-US" sz="1400" dirty="0"/>
           </a:p>
@@ -3989,7 +6348,7 @@
         </p:nvSpPr>
         <p:spPr>
           <a:xfrm>
-            <a:off x="914400" y="1645920"/>
+            <a:off x="914400" y="2011680"/>
             <a:ext cx="10332720" cy="914400"/>
           </a:xfrm>
           <a:prstGeom prst="rect">
@@ -4006,7 +6365,7 @@
               <a:buNone/>
             </a:pPr>
             <a:r>
-              <a:rPr lang="en-US" sz="3600" b="1" dirty="0">
+              <a:rPr lang="en-US" sz="4000" b="1" dirty="0">
                 <a:solidFill>
                   <a:srgbClr val="EC9D2E"/>
                 </a:solidFill>
@@ -4014,22 +6373,42 @@
                 <a:ea typeface="Trebuchet MS" pitchFamily="34" charset="-122"/>
                 <a:cs typeface="Trebuchet MS" pitchFamily="34" charset="-120"/>
               </a:rPr>
-              <a:t>El Futuro de Nuestra Operación Comienza Hoy</a:t>
-            </a:r>
-            <a:endParaRPr lang="en-US" sz="3600" dirty="0"/>
-          </a:p>
-        </p:txBody>
-      </p:sp>
-      <p:sp>
-        <p:nvSpPr>
-          <p:cNvPr id="3" name="Text 1"/>
-          <p:cNvSpPr/>
-          <p:nvPr/>
-        </p:nvSpPr>
-        <p:spPr>
-          <a:xfrm>
-            <a:off x="914400" y="2743200"/>
-            <a:ext cx="9601200" cy="1371600"/>
+              <a:t>Lo Nuevo en Esta Versión</a:t>
+            </a:r>
+            <a:endParaRPr lang="en-US" sz="4000" dirty="0"/>
+          </a:p>
+        </p:txBody>
+      </p:sp>
+      <p:sp>
+        <p:nvSpPr>
+          <p:cNvPr id="3" name="Shape 1"/>
+          <p:cNvSpPr/>
+          <p:nvPr/>
+        </p:nvSpPr>
+        <p:spPr>
+          <a:xfrm>
+            <a:off x="914400" y="2971800"/>
+            <a:ext cx="5486400" cy="36576"/>
+          </a:xfrm>
+          <a:prstGeom prst="rect">
+            <a:avLst/>
+          </a:prstGeom>
+          <a:solidFill>
+            <a:srgbClr val="EC9D2E"/>
+          </a:solidFill>
+          <a:ln/>
+        </p:spPr>
+      </p:sp>
+      <p:sp>
+        <p:nvSpPr>
+          <p:cNvPr id="4" name="Text 2"/>
+          <p:cNvSpPr/>
+          <p:nvPr/>
+        </p:nvSpPr>
+        <p:spPr>
+          <a:xfrm>
+            <a:off x="914400" y="3200400"/>
+            <a:ext cx="10058400" cy="548640"/>
           </a:xfrm>
           <a:prstGeom prst="rect">
             <a:avLst/>
@@ -4042,9 +6421,6 @@
           <a:lstStyle/>
           <a:p>
             <a:pPr indent="0" marL="0">
-              <a:lnSpc>
-                <a:spcPts val="2800"/>
-              </a:lnSpc>
               <a:buNone/>
             </a:pPr>
             <a:r>
@@ -4056,41 +6432,7 @@
                 <a:ea typeface="Arial" pitchFamily="34" charset="-122"/>
                 <a:cs typeface="Arial" pitchFamily="34" charset="-120"/>
               </a:rPr>
-              <a:t>Con BBTI ERP, consolidamos una </a:t>
-            </a:r>
-            <a:pPr indent="0" marL="0">
-              <a:lnSpc>
-                <a:spcPts val="2800"/>
-              </a:lnSpc>
-              <a:buNone/>
-            </a:pPr>
-            <a:r>
-              <a:rPr lang="en-US" sz="1800" b="1" dirty="0">
-                <a:solidFill>
-                  <a:srgbClr val="EC9D2E"/>
-                </a:solidFill>
-                <a:latin typeface="Arial" pitchFamily="34" charset="0"/>
-                <a:ea typeface="Arial" pitchFamily="34" charset="-122"/>
-                <a:cs typeface="Arial" pitchFamily="34" charset="-120"/>
-              </a:rPr>
-              <a:t>planta conectada, transparente y eficiente</a:t>
-            </a:r>
-            <a:pPr indent="0" marL="0">
-              <a:lnSpc>
-                <a:spcPts val="2800"/>
-              </a:lnSpc>
-              <a:buNone/>
-            </a:pPr>
-            <a:r>
-              <a:rPr lang="en-US" sz="1800" dirty="0">
-                <a:solidFill>
-                  <a:srgbClr val="F8FAFC"/>
-                </a:solidFill>
-                <a:latin typeface="Arial" pitchFamily="34" charset="0"/>
-                <a:ea typeface="Arial" pitchFamily="34" charset="-122"/>
-                <a:cs typeface="Arial" pitchFamily="34" charset="-120"/>
-              </a:rPr>
-              <a:t>. Reducimos costos, delimitamos responsabilidades y brindamos a la gerencia la tranquilidad de tener el control total al alcance de su mano.</a:t>
+              <a:t>Mismo sistema, ahora mucho más usable para la Gerencia y los jefes de área</a:t>
             </a:r>
             <a:endParaRPr lang="en-US" sz="1800" dirty="0"/>
           </a:p>
@@ -4098,14 +6440,14 @@
       </p:sp>
       <p:sp>
         <p:nvSpPr>
-          <p:cNvPr id="4" name="Text 2"/>
-          <p:cNvSpPr/>
-          <p:nvPr/>
-        </p:nvSpPr>
-        <p:spPr>
-          <a:xfrm>
-            <a:off x="914400" y="4389120"/>
-            <a:ext cx="10332720" cy="548640"/>
+          <p:cNvPr id="5" name="Text 3"/>
+          <p:cNvSpPr/>
+          <p:nvPr/>
+        </p:nvSpPr>
+        <p:spPr>
+          <a:xfrm>
+            <a:off x="914400" y="3931920"/>
+            <a:ext cx="10058400" cy="548640"/>
           </a:xfrm>
           <a:prstGeom prst="rect">
             <a:avLst/>
@@ -4121,17 +6463,17 @@
               <a:buNone/>
             </a:pPr>
             <a:r>
-              <a:rPr lang="en-US" sz="2000" b="1" dirty="0">
-                <a:solidFill>
-                  <a:srgbClr val="EC9D2E"/>
-                </a:solidFill>
-                <a:latin typeface="Arial" pitchFamily="34" charset="0"/>
-                <a:ea typeface="Arial" pitchFamily="34" charset="-122"/>
-                <a:cs typeface="Arial" pitchFamily="34" charset="-120"/>
-              </a:rPr>
-              <a:t>Muchas Gracias. ¿Preguntas?</a:t>
-            </a:r>
-            <a:endParaRPr lang="en-US" sz="2000" dirty="0"/>
+              <a:rPr lang="en-US" sz="1300" dirty="0">
+                <a:solidFill>
+                  <a:srgbClr val="94A3B8"/>
+                </a:solidFill>
+                <a:latin typeface="Arial" pitchFamily="34" charset="0"/>
+                <a:ea typeface="Arial" pitchFamily="34" charset="-122"/>
+                <a:cs typeface="Arial" pitchFamily="34" charset="-120"/>
+              </a:rPr>
+              <a:t>Inicio en vivo · Alertas automáticas · Productividad por persona · Reportes ejecutivos · Mayor confiabilidad</a:t>
+            </a:r>
+            <a:endParaRPr lang="en-US" sz="1300" dirty="0"/>
           </a:p>
         </p:txBody>
       </p:sp>

</xml_diff>